<commit_message>
testing pipeline and pxrd_query
</commit_message>
<xml_diff>
--- a/DiffractGPT_GSAS_collab.pptx
+++ b/DiffractGPT_GSAS_collab.pptx
@@ -5,7 +5,7 @@
     <p:sldMasterId id="2147483648" r:id="rId1"/>
   </p:sldMasterIdLst>
   <p:sldIdLst>
-    <p:sldId id="256" r:id="rId2"/>
+    <p:sldId id="257" r:id="rId2"/>
   </p:sldIdLst>
   <p:sldSz cx="12192000" cy="6858000"/>
   <p:notesSz cx="6858000" cy="9144000"/>
@@ -110,7 +110,7 @@
 <file path=ppt/revisionInfo.xml><?xml version="1.0" encoding="utf-8"?>
 <p1510:revInfo xmlns:a="http://schemas.openxmlformats.org/drawingml/2006/main" xmlns:r="http://schemas.openxmlformats.org/officeDocument/2006/relationships" xmlns:p1510="http://schemas.microsoft.com/office/powerpoint/2015/10/main">
   <p1510:revLst>
-    <p1510:client id="{44B6F802-407B-4FE7-9025-350E7C46D556}" v="21" dt="2026-02-05T18:29:16.254"/>
+    <p1510:client id="{44B6F802-407B-4FE7-9025-350E7C46D556}" v="37" dt="2026-02-05T21:31:59.036"/>
   </p1510:revLst>
 </p1510:revInfo>
 </file>
@@ -119,13 +119,13 @@
 <pc:chgInfo xmlns:a="http://schemas.openxmlformats.org/drawingml/2006/main" xmlns:r="http://schemas.openxmlformats.org/officeDocument/2006/relationships" xmlns:ac="http://schemas.microsoft.com/office/drawing/2013/main/command" xmlns:pc="http://schemas.microsoft.com/office/powerpoint/2013/main/command">
   <pc:docChgLst>
     <pc:chgData name="Luke Menezes" userId="772ba89cb8294a45" providerId="LiveId" clId="{692EBFBC-5031-428B-A8C8-025FC8EBEFCE}"/>
-    <pc:docChg chg="custSel addSld modSld">
-      <pc:chgData name="Luke Menezes" userId="772ba89cb8294a45" providerId="LiveId" clId="{692EBFBC-5031-428B-A8C8-025FC8EBEFCE}" dt="2026-02-05T18:33:19.133" v="381" actId="1076"/>
+    <pc:docChg chg="custSel addSld delSld modSld">
+      <pc:chgData name="Luke Menezes" userId="772ba89cb8294a45" providerId="LiveId" clId="{692EBFBC-5031-428B-A8C8-025FC8EBEFCE}" dt="2026-02-05T21:33:17.420" v="710"/>
       <pc:docMkLst>
         <pc:docMk/>
       </pc:docMkLst>
-      <pc:sldChg chg="addSp delSp modSp new mod">
-        <pc:chgData name="Luke Menezes" userId="772ba89cb8294a45" providerId="LiveId" clId="{692EBFBC-5031-428B-A8C8-025FC8EBEFCE}" dt="2026-02-05T18:33:19.133" v="381" actId="1076"/>
+      <pc:sldChg chg="addSp delSp modSp new del mod">
+        <pc:chgData name="Luke Menezes" userId="772ba89cb8294a45" providerId="LiveId" clId="{692EBFBC-5031-428B-A8C8-025FC8EBEFCE}" dt="2026-02-05T21:29:38.713" v="701" actId="47"/>
         <pc:sldMkLst>
           <pc:docMk/>
           <pc:sldMk cId="2621669581" sldId="256"/>
@@ -163,7 +163,7 @@
           </ac:spMkLst>
         </pc:spChg>
         <pc:spChg chg="add mod">
-          <ac:chgData name="Luke Menezes" userId="772ba89cb8294a45" providerId="LiveId" clId="{692EBFBC-5031-428B-A8C8-025FC8EBEFCE}" dt="2026-02-05T18:17:46.743" v="147" actId="1076"/>
+          <ac:chgData name="Luke Menezes" userId="772ba89cb8294a45" providerId="LiveId" clId="{692EBFBC-5031-428B-A8C8-025FC8EBEFCE}" dt="2026-02-05T21:18:24.376" v="445" actId="1076"/>
           <ac:spMkLst>
             <pc:docMk/>
             <pc:sldMk cId="2621669581" sldId="256"/>
@@ -171,7 +171,7 @@
           </ac:spMkLst>
         </pc:spChg>
         <pc:spChg chg="add mod">
-          <ac:chgData name="Luke Menezes" userId="772ba89cb8294a45" providerId="LiveId" clId="{692EBFBC-5031-428B-A8C8-025FC8EBEFCE}" dt="2026-02-05T18:18:47.141" v="223" actId="1076"/>
+          <ac:chgData name="Luke Menezes" userId="772ba89cb8294a45" providerId="LiveId" clId="{692EBFBC-5031-428B-A8C8-025FC8EBEFCE}" dt="2026-02-05T21:18:24.376" v="445" actId="1076"/>
           <ac:spMkLst>
             <pc:docMk/>
             <pc:sldMk cId="2621669581" sldId="256"/>
@@ -179,7 +179,7 @@
           </ac:spMkLst>
         </pc:spChg>
         <pc:spChg chg="add mod">
-          <ac:chgData name="Luke Menezes" userId="772ba89cb8294a45" providerId="LiveId" clId="{692EBFBC-5031-428B-A8C8-025FC8EBEFCE}" dt="2026-02-05T18:27:15.238" v="352" actId="20577"/>
+          <ac:chgData name="Luke Menezes" userId="772ba89cb8294a45" providerId="LiveId" clId="{692EBFBC-5031-428B-A8C8-025FC8EBEFCE}" dt="2026-02-05T21:18:24.376" v="445" actId="1076"/>
           <ac:spMkLst>
             <pc:docMk/>
             <pc:sldMk cId="2621669581" sldId="256"/>
@@ -187,7 +187,7 @@
           </ac:spMkLst>
         </pc:spChg>
         <pc:spChg chg="add mod">
-          <ac:chgData name="Luke Menezes" userId="772ba89cb8294a45" providerId="LiveId" clId="{692EBFBC-5031-428B-A8C8-025FC8EBEFCE}" dt="2026-02-05T18:20:51.455" v="250" actId="1076"/>
+          <ac:chgData name="Luke Menezes" userId="772ba89cb8294a45" providerId="LiveId" clId="{692EBFBC-5031-428B-A8C8-025FC8EBEFCE}" dt="2026-02-05T21:18:24.376" v="445" actId="1076"/>
           <ac:spMkLst>
             <pc:docMk/>
             <pc:sldMk cId="2621669581" sldId="256"/>
@@ -195,7 +195,7 @@
           </ac:spMkLst>
         </pc:spChg>
         <pc:spChg chg="add mod">
-          <ac:chgData name="Luke Menezes" userId="772ba89cb8294a45" providerId="LiveId" clId="{692EBFBC-5031-428B-A8C8-025FC8EBEFCE}" dt="2026-02-05T18:22:39.797" v="268" actId="1076"/>
+          <ac:chgData name="Luke Menezes" userId="772ba89cb8294a45" providerId="LiveId" clId="{692EBFBC-5031-428B-A8C8-025FC8EBEFCE}" dt="2026-02-05T21:18:24.376" v="445" actId="1076"/>
           <ac:spMkLst>
             <pc:docMk/>
             <pc:sldMk cId="2621669581" sldId="256"/>
@@ -203,7 +203,7 @@
           </ac:spMkLst>
         </pc:spChg>
         <pc:spChg chg="add mod">
-          <ac:chgData name="Luke Menezes" userId="772ba89cb8294a45" providerId="LiveId" clId="{692EBFBC-5031-428B-A8C8-025FC8EBEFCE}" dt="2026-02-05T18:23:25.585" v="276" actId="1076"/>
+          <ac:chgData name="Luke Menezes" userId="772ba89cb8294a45" providerId="LiveId" clId="{692EBFBC-5031-428B-A8C8-025FC8EBEFCE}" dt="2026-02-05T21:18:24.376" v="445" actId="1076"/>
           <ac:spMkLst>
             <pc:docMk/>
             <pc:sldMk cId="2621669581" sldId="256"/>
@@ -211,7 +211,7 @@
           </ac:spMkLst>
         </pc:spChg>
         <pc:spChg chg="add mod">
-          <ac:chgData name="Luke Menezes" userId="772ba89cb8294a45" providerId="LiveId" clId="{692EBFBC-5031-428B-A8C8-025FC8EBEFCE}" dt="2026-02-05T18:24:22.832" v="293" actId="1076"/>
+          <ac:chgData name="Luke Menezes" userId="772ba89cb8294a45" providerId="LiveId" clId="{692EBFBC-5031-428B-A8C8-025FC8EBEFCE}" dt="2026-02-05T21:18:24.376" v="445" actId="1076"/>
           <ac:spMkLst>
             <pc:docMk/>
             <pc:sldMk cId="2621669581" sldId="256"/>
@@ -219,7 +219,7 @@
           </ac:spMkLst>
         </pc:spChg>
         <pc:spChg chg="add mod">
-          <ac:chgData name="Luke Menezes" userId="772ba89cb8294a45" providerId="LiveId" clId="{692EBFBC-5031-428B-A8C8-025FC8EBEFCE}" dt="2026-02-05T18:27:31.613" v="367" actId="20577"/>
+          <ac:chgData name="Luke Menezes" userId="772ba89cb8294a45" providerId="LiveId" clId="{692EBFBC-5031-428B-A8C8-025FC8EBEFCE}" dt="2026-02-05T21:18:24.376" v="445" actId="1076"/>
           <ac:spMkLst>
             <pc:docMk/>
             <pc:sldMk cId="2621669581" sldId="256"/>
@@ -227,11 +227,35 @@
           </ac:spMkLst>
         </pc:spChg>
         <pc:spChg chg="add mod">
-          <ac:chgData name="Luke Menezes" userId="772ba89cb8294a45" providerId="LiveId" clId="{692EBFBC-5031-428B-A8C8-025FC8EBEFCE}" dt="2026-02-05T18:29:16.254" v="371"/>
+          <ac:chgData name="Luke Menezes" userId="772ba89cb8294a45" providerId="LiveId" clId="{692EBFBC-5031-428B-A8C8-025FC8EBEFCE}" dt="2026-02-05T21:18:24.376" v="445" actId="1076"/>
           <ac:spMkLst>
             <pc:docMk/>
             <pc:sldMk cId="2621669581" sldId="256"/>
             <ac:spMk id="48" creationId="{F2B007B2-1D83-6F71-C166-6FFA99ED2C96}"/>
+          </ac:spMkLst>
+        </pc:spChg>
+        <pc:spChg chg="add mod">
+          <ac:chgData name="Luke Menezes" userId="772ba89cb8294a45" providerId="LiveId" clId="{692EBFBC-5031-428B-A8C8-025FC8EBEFCE}" dt="2026-02-05T21:18:24.376" v="445" actId="1076"/>
+          <ac:spMkLst>
+            <pc:docMk/>
+            <pc:sldMk cId="2621669581" sldId="256"/>
+            <ac:spMk id="51" creationId="{C25389DA-34F9-ADB0-5562-7670FBD1F317}"/>
+          </ac:spMkLst>
+        </pc:spChg>
+        <pc:spChg chg="add mod ord">
+          <ac:chgData name="Luke Menezes" userId="772ba89cb8294a45" providerId="LiveId" clId="{692EBFBC-5031-428B-A8C8-025FC8EBEFCE}" dt="2026-02-05T21:20:14.418" v="546" actId="14100"/>
+          <ac:spMkLst>
+            <pc:docMk/>
+            <pc:sldMk cId="2621669581" sldId="256"/>
+            <ac:spMk id="52" creationId="{49EADC6D-D803-0864-DC06-DD3A1FE82988}"/>
+          </ac:spMkLst>
+        </pc:spChg>
+        <pc:spChg chg="add mod">
+          <ac:chgData name="Luke Menezes" userId="772ba89cb8294a45" providerId="LiveId" clId="{692EBFBC-5031-428B-A8C8-025FC8EBEFCE}" dt="2026-02-05T21:20:17.779" v="547" actId="1076"/>
+          <ac:spMkLst>
+            <pc:docMk/>
+            <pc:sldMk cId="2621669581" sldId="256"/>
+            <ac:spMk id="53" creationId="{46C2019A-AE89-4780-4C22-1F39657AF596}"/>
           </ac:spMkLst>
         </pc:spChg>
         <pc:picChg chg="add mod">
@@ -282,6 +306,14 @@
             <ac:picMk id="50" creationId="{110065EC-3090-35B7-FDB9-C613E2DE7518}"/>
           </ac:picMkLst>
         </pc:picChg>
+        <pc:picChg chg="add del mod">
+          <ac:chgData name="Luke Menezes" userId="772ba89cb8294a45" providerId="LiveId" clId="{692EBFBC-5031-428B-A8C8-025FC8EBEFCE}" dt="2026-02-05T21:21:22.984" v="551" actId="478"/>
+          <ac:picMkLst>
+            <pc:docMk/>
+            <pc:sldMk cId="2621669581" sldId="256"/>
+            <ac:picMk id="55" creationId="{A6B24AC3-9AA8-AF9D-1002-3911B264C2F7}"/>
+          </ac:picMkLst>
+        </pc:picChg>
         <pc:cxnChg chg="add mod">
           <ac:chgData name="Luke Menezes" userId="772ba89cb8294a45" providerId="LiveId" clId="{692EBFBC-5031-428B-A8C8-025FC8EBEFCE}" dt="2026-02-05T18:20:17.763" v="244" actId="1582"/>
           <ac:cxnSpMkLst>
@@ -368,6 +400,349 @@
             <pc:docMk/>
             <pc:sldMk cId="2621669581" sldId="256"/>
             <ac:cxnSpMk id="46" creationId="{8BDFA182-522E-8CF6-A43D-57BB0041731C}"/>
+          </ac:cxnSpMkLst>
+        </pc:cxnChg>
+      </pc:sldChg>
+      <pc:sldChg chg="addSp delSp modSp add mod addAnim delAnim modAnim">
+        <pc:chgData name="Luke Menezes" userId="772ba89cb8294a45" providerId="LiveId" clId="{692EBFBC-5031-428B-A8C8-025FC8EBEFCE}" dt="2026-02-05T21:33:17.420" v="710"/>
+        <pc:sldMkLst>
+          <pc:docMk/>
+          <pc:sldMk cId="2566389466" sldId="257"/>
+        </pc:sldMkLst>
+        <pc:spChg chg="add mod">
+          <ac:chgData name="Luke Menezes" userId="772ba89cb8294a45" providerId="LiveId" clId="{692EBFBC-5031-428B-A8C8-025FC8EBEFCE}" dt="2026-02-05T21:29:35.475" v="700" actId="1076"/>
+          <ac:spMkLst>
+            <pc:docMk/>
+            <pc:sldMk cId="2566389466" sldId="257"/>
+            <ac:spMk id="2" creationId="{B3888715-AE2B-DB5F-83D9-104D375BE2C8}"/>
+          </ac:spMkLst>
+        </pc:spChg>
+        <pc:spChg chg="add mod">
+          <ac:chgData name="Luke Menezes" userId="772ba89cb8294a45" providerId="LiveId" clId="{692EBFBC-5031-428B-A8C8-025FC8EBEFCE}" dt="2026-02-05T21:27:47.989" v="684" actId="14100"/>
+          <ac:spMkLst>
+            <pc:docMk/>
+            <pc:sldMk cId="2566389466" sldId="257"/>
+            <ac:spMk id="3" creationId="{4B89558D-8DCE-1819-0DF3-B8780591612E}"/>
+          </ac:spMkLst>
+        </pc:spChg>
+        <pc:spChg chg="del mod">
+          <ac:chgData name="Luke Menezes" userId="772ba89cb8294a45" providerId="LiveId" clId="{692EBFBC-5031-428B-A8C8-025FC8EBEFCE}" dt="2026-02-05T21:21:35.745" v="556" actId="478"/>
+          <ac:spMkLst>
+            <pc:docMk/>
+            <pc:sldMk cId="2566389466" sldId="257"/>
+            <ac:spMk id="6" creationId="{0DDE7B3A-FEA1-6208-71FC-CFD0260CAAA6}"/>
+          </ac:spMkLst>
+        </pc:spChg>
+        <pc:spChg chg="del">
+          <ac:chgData name="Luke Menezes" userId="772ba89cb8294a45" providerId="LiveId" clId="{692EBFBC-5031-428B-A8C8-025FC8EBEFCE}" dt="2026-02-05T21:21:37.691" v="558" actId="478"/>
+          <ac:spMkLst>
+            <pc:docMk/>
+            <pc:sldMk cId="2566389466" sldId="257"/>
+            <ac:spMk id="7" creationId="{0C626518-1242-04AD-AA03-2E12E44047E1}"/>
+          </ac:spMkLst>
+        </pc:spChg>
+        <pc:spChg chg="del">
+          <ac:chgData name="Luke Menezes" userId="772ba89cb8294a45" providerId="LiveId" clId="{692EBFBC-5031-428B-A8C8-025FC8EBEFCE}" dt="2026-02-05T21:21:31.116" v="554" actId="478"/>
+          <ac:spMkLst>
+            <pc:docMk/>
+            <pc:sldMk cId="2566389466" sldId="257"/>
+            <ac:spMk id="10" creationId="{DFFE8C81-F154-E6A1-B911-F6E42E0FAD01}"/>
+          </ac:spMkLst>
+        </pc:spChg>
+        <pc:spChg chg="del">
+          <ac:chgData name="Luke Menezes" userId="772ba89cb8294a45" providerId="LiveId" clId="{692EBFBC-5031-428B-A8C8-025FC8EBEFCE}" dt="2026-02-05T21:21:31.116" v="554" actId="478"/>
+          <ac:spMkLst>
+            <pc:docMk/>
+            <pc:sldMk cId="2566389466" sldId="257"/>
+            <ac:spMk id="11" creationId="{7A614EFF-B2DF-627C-08FF-BC957C5065FB}"/>
+          </ac:spMkLst>
+        </pc:spChg>
+        <pc:spChg chg="add mod">
+          <ac:chgData name="Luke Menezes" userId="772ba89cb8294a45" providerId="LiveId" clId="{692EBFBC-5031-428B-A8C8-025FC8EBEFCE}" dt="2026-02-05T21:29:35.475" v="700" actId="1076"/>
+          <ac:spMkLst>
+            <pc:docMk/>
+            <pc:sldMk cId="2566389466" sldId="257"/>
+            <ac:spMk id="17" creationId="{75CCC608-F474-1969-8AE1-2965F5E770C9}"/>
+          </ac:spMkLst>
+        </pc:spChg>
+        <pc:spChg chg="del">
+          <ac:chgData name="Luke Menezes" userId="772ba89cb8294a45" providerId="LiveId" clId="{692EBFBC-5031-428B-A8C8-025FC8EBEFCE}" dt="2026-02-05T21:21:31.116" v="554" actId="478"/>
+          <ac:spMkLst>
+            <pc:docMk/>
+            <pc:sldMk cId="2566389466" sldId="257"/>
+            <ac:spMk id="20" creationId="{F1A4A070-72DB-97D6-71ED-E97FAFB0E391}"/>
+          </ac:spMkLst>
+        </pc:spChg>
+        <pc:spChg chg="add mod">
+          <ac:chgData name="Luke Menezes" userId="772ba89cb8294a45" providerId="LiveId" clId="{692EBFBC-5031-428B-A8C8-025FC8EBEFCE}" dt="2026-02-05T21:29:35.475" v="700" actId="1076"/>
+          <ac:spMkLst>
+            <pc:docMk/>
+            <pc:sldMk cId="2566389466" sldId="257"/>
+            <ac:spMk id="22" creationId="{42C2EE16-0D47-46BC-0FCB-78BA564AB2E6}"/>
+          </ac:spMkLst>
+        </pc:spChg>
+        <pc:spChg chg="del">
+          <ac:chgData name="Luke Menezes" userId="772ba89cb8294a45" providerId="LiveId" clId="{692EBFBC-5031-428B-A8C8-025FC8EBEFCE}" dt="2026-02-05T21:21:31.116" v="554" actId="478"/>
+          <ac:spMkLst>
+            <pc:docMk/>
+            <pc:sldMk cId="2566389466" sldId="257"/>
+            <ac:spMk id="23" creationId="{0DFD051E-B811-CD74-FA2A-016ABE399B93}"/>
+          </ac:spMkLst>
+        </pc:spChg>
+        <pc:spChg chg="del">
+          <ac:chgData name="Luke Menezes" userId="772ba89cb8294a45" providerId="LiveId" clId="{692EBFBC-5031-428B-A8C8-025FC8EBEFCE}" dt="2026-02-05T21:21:31.116" v="554" actId="478"/>
+          <ac:spMkLst>
+            <pc:docMk/>
+            <pc:sldMk cId="2566389466" sldId="257"/>
+            <ac:spMk id="24" creationId="{398A48C8-0288-C2FF-9846-5ACEEC530A91}"/>
+          </ac:spMkLst>
+        </pc:spChg>
+        <pc:spChg chg="add mod">
+          <ac:chgData name="Luke Menezes" userId="772ba89cb8294a45" providerId="LiveId" clId="{692EBFBC-5031-428B-A8C8-025FC8EBEFCE}" dt="2026-02-05T21:29:35.475" v="700" actId="1076"/>
+          <ac:spMkLst>
+            <pc:docMk/>
+            <pc:sldMk cId="2566389466" sldId="257"/>
+            <ac:spMk id="28" creationId="{2EC9EAB1-42C3-B9BA-A64C-92E9CAF2506A}"/>
+          </ac:spMkLst>
+        </pc:spChg>
+        <pc:spChg chg="del">
+          <ac:chgData name="Luke Menezes" userId="772ba89cb8294a45" providerId="LiveId" clId="{692EBFBC-5031-428B-A8C8-025FC8EBEFCE}" dt="2026-02-05T21:21:31.116" v="554" actId="478"/>
+          <ac:spMkLst>
+            <pc:docMk/>
+            <pc:sldMk cId="2566389466" sldId="257"/>
+            <ac:spMk id="29" creationId="{99ADDCE3-CB3F-0D14-9933-81B9D44F68EE}"/>
+          </ac:spMkLst>
+        </pc:spChg>
+        <pc:spChg chg="add mod">
+          <ac:chgData name="Luke Menezes" userId="772ba89cb8294a45" providerId="LiveId" clId="{692EBFBC-5031-428B-A8C8-025FC8EBEFCE}" dt="2026-02-05T21:29:35.475" v="700" actId="1076"/>
+          <ac:spMkLst>
+            <pc:docMk/>
+            <pc:sldMk cId="2566389466" sldId="257"/>
+            <ac:spMk id="32" creationId="{ECF9F37E-58D7-03F4-2A82-398D3CC1A4C7}"/>
+          </ac:spMkLst>
+        </pc:spChg>
+        <pc:spChg chg="add mod">
+          <ac:chgData name="Luke Menezes" userId="772ba89cb8294a45" providerId="LiveId" clId="{692EBFBC-5031-428B-A8C8-025FC8EBEFCE}" dt="2026-02-05T21:29:35.475" v="700" actId="1076"/>
+          <ac:spMkLst>
+            <pc:docMk/>
+            <pc:sldMk cId="2566389466" sldId="257"/>
+            <ac:spMk id="35" creationId="{B2C32301-3DB9-DB28-015D-9AEFEDAA2AE4}"/>
+          </ac:spMkLst>
+        </pc:spChg>
+        <pc:spChg chg="add del mod">
+          <ac:chgData name="Luke Menezes" userId="772ba89cb8294a45" providerId="LiveId" clId="{692EBFBC-5031-428B-A8C8-025FC8EBEFCE}" dt="2026-02-05T21:32:38.480" v="705" actId="478"/>
+          <ac:spMkLst>
+            <pc:docMk/>
+            <pc:sldMk cId="2566389466" sldId="257"/>
+            <ac:spMk id="36" creationId="{62F71070-BEC2-1D90-4D44-50F97FF29D8D}"/>
+          </ac:spMkLst>
+        </pc:spChg>
+        <pc:spChg chg="add mod">
+          <ac:chgData name="Luke Menezes" userId="772ba89cb8294a45" providerId="LiveId" clId="{692EBFBC-5031-428B-A8C8-025FC8EBEFCE}" dt="2026-02-05T21:29:35.475" v="700" actId="1076"/>
+          <ac:spMkLst>
+            <pc:docMk/>
+            <pc:sldMk cId="2566389466" sldId="257"/>
+            <ac:spMk id="37" creationId="{DE0BEFA4-B1B6-D889-6003-BD6CE1F04782}"/>
+          </ac:spMkLst>
+        </pc:spChg>
+        <pc:spChg chg="add mod">
+          <ac:chgData name="Luke Menezes" userId="772ba89cb8294a45" providerId="LiveId" clId="{692EBFBC-5031-428B-A8C8-025FC8EBEFCE}" dt="2026-02-05T21:29:35.475" v="700" actId="1076"/>
+          <ac:spMkLst>
+            <pc:docMk/>
+            <pc:sldMk cId="2566389466" sldId="257"/>
+            <ac:spMk id="41" creationId="{A1B95DCA-0DA6-3573-52DF-0B909CEBC1B8}"/>
+          </ac:spMkLst>
+        </pc:spChg>
+        <pc:spChg chg="add mod">
+          <ac:chgData name="Luke Menezes" userId="772ba89cb8294a45" providerId="LiveId" clId="{692EBFBC-5031-428B-A8C8-025FC8EBEFCE}" dt="2026-02-05T21:29:35.475" v="700" actId="1076"/>
+          <ac:spMkLst>
+            <pc:docMk/>
+            <pc:sldMk cId="2566389466" sldId="257"/>
+            <ac:spMk id="47" creationId="{4DD67034-12EC-B126-1918-86B9C3D6C8DB}"/>
+          </ac:spMkLst>
+        </pc:spChg>
+        <pc:spChg chg="del">
+          <ac:chgData name="Luke Menezes" userId="772ba89cb8294a45" providerId="LiveId" clId="{692EBFBC-5031-428B-A8C8-025FC8EBEFCE}" dt="2026-02-05T21:21:31.116" v="554" actId="478"/>
+          <ac:spMkLst>
+            <pc:docMk/>
+            <pc:sldMk cId="2566389466" sldId="257"/>
+            <ac:spMk id="48" creationId="{D77A634C-5C06-BD0A-7918-316A3BB52624}"/>
+          </ac:spMkLst>
+        </pc:spChg>
+        <pc:spChg chg="del">
+          <ac:chgData name="Luke Menezes" userId="772ba89cb8294a45" providerId="LiveId" clId="{692EBFBC-5031-428B-A8C8-025FC8EBEFCE}" dt="2026-02-05T21:21:40.866" v="561" actId="478"/>
+          <ac:spMkLst>
+            <pc:docMk/>
+            <pc:sldMk cId="2566389466" sldId="257"/>
+            <ac:spMk id="51" creationId="{A0612F3F-22C7-5884-390C-B768B93851C3}"/>
+          </ac:spMkLst>
+        </pc:spChg>
+        <pc:spChg chg="del">
+          <ac:chgData name="Luke Menezes" userId="772ba89cb8294a45" providerId="LiveId" clId="{692EBFBC-5031-428B-A8C8-025FC8EBEFCE}" dt="2026-02-05T21:21:31.116" v="554" actId="478"/>
+          <ac:spMkLst>
+            <pc:docMk/>
+            <pc:sldMk cId="2566389466" sldId="257"/>
+            <ac:spMk id="52" creationId="{08F52C19-CA99-2B55-296F-9F3956E6615E}"/>
+          </ac:spMkLst>
+        </pc:spChg>
+        <pc:spChg chg="del">
+          <ac:chgData name="Luke Menezes" userId="772ba89cb8294a45" providerId="LiveId" clId="{692EBFBC-5031-428B-A8C8-025FC8EBEFCE}" dt="2026-02-05T21:21:31.116" v="554" actId="478"/>
+          <ac:spMkLst>
+            <pc:docMk/>
+            <pc:sldMk cId="2566389466" sldId="257"/>
+            <ac:spMk id="53" creationId="{F1A35C80-F93F-1E34-7D40-640E302A202A}"/>
+          </ac:spMkLst>
+        </pc:spChg>
+        <pc:picChg chg="del">
+          <ac:chgData name="Luke Menezes" userId="772ba89cb8294a45" providerId="LiveId" clId="{692EBFBC-5031-428B-A8C8-025FC8EBEFCE}" dt="2026-02-05T21:21:36.445" v="557" actId="478"/>
+          <ac:picMkLst>
+            <pc:docMk/>
+            <pc:sldMk cId="2566389466" sldId="257"/>
+            <ac:picMk id="9" creationId="{FC69D4D2-D662-DF0F-E531-D40928033462}"/>
+          </ac:picMkLst>
+        </pc:picChg>
+        <pc:picChg chg="del">
+          <ac:chgData name="Luke Menezes" userId="772ba89cb8294a45" providerId="LiveId" clId="{692EBFBC-5031-428B-A8C8-025FC8EBEFCE}" dt="2026-02-05T21:21:43.399" v="563" actId="478"/>
+          <ac:picMkLst>
+            <pc:docMk/>
+            <pc:sldMk cId="2566389466" sldId="257"/>
+            <ac:picMk id="18" creationId="{7717EF43-EF94-FE59-F663-DFD191B4F561}"/>
+          </ac:picMkLst>
+        </pc:picChg>
+        <pc:picChg chg="add mod">
+          <ac:chgData name="Luke Menezes" userId="772ba89cb8294a45" providerId="LiveId" clId="{692EBFBC-5031-428B-A8C8-025FC8EBEFCE}" dt="2026-02-05T21:23:54.996" v="638" actId="1076"/>
+          <ac:picMkLst>
+            <pc:docMk/>
+            <pc:sldMk cId="2566389466" sldId="257"/>
+            <ac:picMk id="21" creationId="{1ADA9D8D-F949-F58F-6B92-FD80ABA07DFE}"/>
+          </ac:picMkLst>
+        </pc:picChg>
+        <pc:picChg chg="add mod">
+          <ac:chgData name="Luke Menezes" userId="772ba89cb8294a45" providerId="LiveId" clId="{692EBFBC-5031-428B-A8C8-025FC8EBEFCE}" dt="2026-02-05T21:27:55.315" v="686" actId="1076"/>
+          <ac:picMkLst>
+            <pc:docMk/>
+            <pc:sldMk cId="2566389466" sldId="257"/>
+            <ac:picMk id="34" creationId="{4E42EBD3-4C75-15E0-CE4B-A10868E2491B}"/>
+          </ac:picMkLst>
+        </pc:picChg>
+        <pc:picChg chg="add del mod">
+          <ac:chgData name="Luke Menezes" userId="772ba89cb8294a45" providerId="LiveId" clId="{692EBFBC-5031-428B-A8C8-025FC8EBEFCE}" dt="2026-02-05T21:26:49.920" v="673" actId="478"/>
+          <ac:picMkLst>
+            <pc:docMk/>
+            <pc:sldMk cId="2566389466" sldId="257"/>
+            <ac:picMk id="44" creationId="{771C3B43-5C11-EA84-20A3-733FC7C95E4B}"/>
+          </ac:picMkLst>
+        </pc:picChg>
+        <pc:picChg chg="del">
+          <ac:chgData name="Luke Menezes" userId="772ba89cb8294a45" providerId="LiveId" clId="{692EBFBC-5031-428B-A8C8-025FC8EBEFCE}" dt="2026-02-05T21:21:31.116" v="554" actId="478"/>
+          <ac:picMkLst>
+            <pc:docMk/>
+            <pc:sldMk cId="2566389466" sldId="257"/>
+            <ac:picMk id="50" creationId="{FABF1FEA-446A-9ADB-0AC3-CD5D60BC8386}"/>
+          </ac:picMkLst>
+        </pc:picChg>
+        <pc:picChg chg="mod">
+          <ac:chgData name="Luke Menezes" userId="772ba89cb8294a45" providerId="LiveId" clId="{692EBFBC-5031-428B-A8C8-025FC8EBEFCE}" dt="2026-02-05T21:27:49.390" v="685" actId="1076"/>
+          <ac:picMkLst>
+            <pc:docMk/>
+            <pc:sldMk cId="2566389466" sldId="257"/>
+            <ac:picMk id="55" creationId="{FC9279A9-3F5E-4C1A-3C18-CE60FD667FB7}"/>
+          </ac:picMkLst>
+        </pc:picChg>
+        <pc:cxnChg chg="add mod">
+          <ac:chgData name="Luke Menezes" userId="772ba89cb8294a45" providerId="LiveId" clId="{692EBFBC-5031-428B-A8C8-025FC8EBEFCE}" dt="2026-02-05T21:23:41.877" v="636" actId="14100"/>
+          <ac:cxnSpMkLst>
+            <pc:docMk/>
+            <pc:sldMk cId="2566389466" sldId="257"/>
+            <ac:cxnSpMk id="8" creationId="{2B007ADB-659F-A154-6F86-79900B7ED942}"/>
+          </ac:cxnSpMkLst>
+        </pc:cxnChg>
+        <pc:cxnChg chg="del">
+          <ac:chgData name="Luke Menezes" userId="772ba89cb8294a45" providerId="LiveId" clId="{692EBFBC-5031-428B-A8C8-025FC8EBEFCE}" dt="2026-02-05T21:21:38.818" v="559" actId="478"/>
+          <ac:cxnSpMkLst>
+            <pc:docMk/>
+            <pc:sldMk cId="2566389466" sldId="257"/>
+            <ac:cxnSpMk id="13" creationId="{F9CFCD0F-E5A3-5D58-91EE-77BC36E0B383}"/>
+          </ac:cxnSpMkLst>
+        </pc:cxnChg>
+        <pc:cxnChg chg="add mod">
+          <ac:chgData name="Luke Menezes" userId="772ba89cb8294a45" providerId="LiveId" clId="{692EBFBC-5031-428B-A8C8-025FC8EBEFCE}" dt="2026-02-05T21:24:51.940" v="647" actId="1076"/>
+          <ac:cxnSpMkLst>
+            <pc:docMk/>
+            <pc:sldMk cId="2566389466" sldId="257"/>
+            <ac:cxnSpMk id="26" creationId="{583F366C-2102-77F0-89F2-08EF688C3367}"/>
+          </ac:cxnSpMkLst>
+        </pc:cxnChg>
+        <pc:cxnChg chg="add del mod">
+          <ac:chgData name="Luke Menezes" userId="772ba89cb8294a45" providerId="LiveId" clId="{692EBFBC-5031-428B-A8C8-025FC8EBEFCE}" dt="2026-02-05T21:25:03.647" v="649" actId="478"/>
+          <ac:cxnSpMkLst>
+            <pc:docMk/>
+            <pc:sldMk cId="2566389466" sldId="257"/>
+            <ac:cxnSpMk id="33" creationId="{99DFCE9F-E690-32B5-FAEC-76067469A1E9}"/>
+          </ac:cxnSpMkLst>
+        </pc:cxnChg>
+        <pc:cxnChg chg="add mod">
+          <ac:chgData name="Luke Menezes" userId="772ba89cb8294a45" providerId="LiveId" clId="{692EBFBC-5031-428B-A8C8-025FC8EBEFCE}" dt="2026-02-05T21:28:04.015" v="688" actId="1076"/>
+          <ac:cxnSpMkLst>
+            <pc:docMk/>
+            <pc:sldMk cId="2566389466" sldId="257"/>
+            <ac:cxnSpMk id="38" creationId="{047A3B81-746A-22E6-AB0D-F6F8D9092E31}"/>
+          </ac:cxnSpMkLst>
+        </pc:cxnChg>
+        <pc:cxnChg chg="add mod">
+          <ac:chgData name="Luke Menezes" userId="772ba89cb8294a45" providerId="LiveId" clId="{692EBFBC-5031-428B-A8C8-025FC8EBEFCE}" dt="2026-02-05T21:28:01.902" v="687" actId="1076"/>
+          <ac:cxnSpMkLst>
+            <pc:docMk/>
+            <pc:sldMk cId="2566389466" sldId="257"/>
+            <ac:cxnSpMk id="40" creationId="{42769015-40F4-4FED-D0C7-50B536386FC6}"/>
+          </ac:cxnSpMkLst>
+        </pc:cxnChg>
+        <pc:cxnChg chg="del">
+          <ac:chgData name="Luke Menezes" userId="772ba89cb8294a45" providerId="LiveId" clId="{692EBFBC-5031-428B-A8C8-025FC8EBEFCE}" dt="2026-02-05T21:21:39.833" v="560" actId="478"/>
+          <ac:cxnSpMkLst>
+            <pc:docMk/>
+            <pc:sldMk cId="2566389466" sldId="257"/>
+            <ac:cxnSpMk id="42" creationId="{058C8E85-0419-154C-E40D-D45BB6F9C55C}"/>
+          </ac:cxnSpMkLst>
+        </pc:cxnChg>
+        <pc:cxnChg chg="del">
+          <ac:chgData name="Luke Menezes" userId="772ba89cb8294a45" providerId="LiveId" clId="{692EBFBC-5031-428B-A8C8-025FC8EBEFCE}" dt="2026-02-05T21:21:44.086" v="564" actId="478"/>
+          <ac:cxnSpMkLst>
+            <pc:docMk/>
+            <pc:sldMk cId="2566389466" sldId="257"/>
+            <ac:cxnSpMk id="43" creationId="{A85A6B4B-2188-5C4F-F728-6B7A5A799F89}"/>
+          </ac:cxnSpMkLst>
+        </pc:cxnChg>
+        <pc:cxnChg chg="add mod">
+          <ac:chgData name="Luke Menezes" userId="772ba89cb8294a45" providerId="LiveId" clId="{692EBFBC-5031-428B-A8C8-025FC8EBEFCE}" dt="2026-02-05T21:25:57.348" v="658" actId="14100"/>
+          <ac:cxnSpMkLst>
+            <pc:docMk/>
+            <pc:sldMk cId="2566389466" sldId="257"/>
+            <ac:cxnSpMk id="45" creationId="{B1FDC02B-F52B-48C1-7575-E26F701EEA55}"/>
+          </ac:cxnSpMkLst>
+        </pc:cxnChg>
+        <pc:cxnChg chg="add mod">
+          <ac:chgData name="Luke Menezes" userId="772ba89cb8294a45" providerId="LiveId" clId="{692EBFBC-5031-428B-A8C8-025FC8EBEFCE}" dt="2026-02-05T21:28:14.229" v="691" actId="14100"/>
+          <ac:cxnSpMkLst>
+            <pc:docMk/>
+            <pc:sldMk cId="2566389466" sldId="257"/>
+            <ac:cxnSpMk id="57" creationId="{D2C9358E-6560-60E3-F78D-E9C0103E77A8}"/>
+          </ac:cxnSpMkLst>
+        </pc:cxnChg>
+        <pc:cxnChg chg="add mod">
+          <ac:chgData name="Luke Menezes" userId="772ba89cb8294a45" providerId="LiveId" clId="{692EBFBC-5031-428B-A8C8-025FC8EBEFCE}" dt="2026-02-05T21:28:34.284" v="695" actId="14100"/>
+          <ac:cxnSpMkLst>
+            <pc:docMk/>
+            <pc:sldMk cId="2566389466" sldId="257"/>
+            <ac:cxnSpMk id="59" creationId="{B3986487-D77E-5749-0CB6-B043103196A2}"/>
+          </ac:cxnSpMkLst>
+        </pc:cxnChg>
+        <pc:cxnChg chg="add mod">
+          <ac:chgData name="Luke Menezes" userId="772ba89cb8294a45" providerId="LiveId" clId="{692EBFBC-5031-428B-A8C8-025FC8EBEFCE}" dt="2026-02-05T21:28:51.208" v="699" actId="14100"/>
+          <ac:cxnSpMkLst>
+            <pc:docMk/>
+            <pc:sldMk cId="2566389466" sldId="257"/>
+            <ac:cxnSpMk id="61" creationId="{E018BF38-1A4F-AE25-C7C8-708DBC5D58F2}"/>
           </ac:cxnSpMkLst>
         </pc:cxnChg>
       </pc:sldChg>
@@ -3578,7 +3953,13 @@
   <p:cSld>
     <p:spTree>
       <p:nvGrpSpPr>
-        <p:cNvPr id="1" name=""/>
+        <p:cNvPr id="1" name="">
+          <a:extLst>
+            <a:ext uri="{FF2B5EF4-FFF2-40B4-BE49-F238E27FC236}">
+              <a16:creationId xmlns:a16="http://schemas.microsoft.com/office/drawing/2014/main" id="{CDB1052E-079B-AB3B-DEE6-12DAA6C9D9C4}"/>
+            </a:ext>
+          </a:extLst>
+        </p:cNvPr>
         <p:cNvGrpSpPr/>
         <p:nvPr/>
       </p:nvGrpSpPr>
@@ -3595,7 +3976,7 @@
           <p:cNvPr id="4" name="TextBox 3">
             <a:extLst>
               <a:ext uri="{FF2B5EF4-FFF2-40B4-BE49-F238E27FC236}">
-                <a16:creationId xmlns:a16="http://schemas.microsoft.com/office/drawing/2014/main" id="{25D6340F-0950-C8DD-6B53-A2B75346A933}"/>
+                <a16:creationId xmlns:a16="http://schemas.microsoft.com/office/drawing/2014/main" id="{CD449DE1-D0B9-DD44-CC2F-A88CB36D4EB2}"/>
               </a:ext>
             </a:extLst>
           </p:cNvPr>
@@ -3640,7 +4021,7 @@
           <p:cNvPr id="5" name="Rectangle 4">
             <a:extLst>
               <a:ext uri="{FF2B5EF4-FFF2-40B4-BE49-F238E27FC236}">
-                <a16:creationId xmlns:a16="http://schemas.microsoft.com/office/drawing/2014/main" id="{2803556F-1762-5EB6-A15D-D650924E64EC}"/>
+                <a16:creationId xmlns:a16="http://schemas.microsoft.com/office/drawing/2014/main" id="{626D7086-6C03-920C-08B8-A4848BC3A773}"/>
               </a:ext>
             </a:extLst>
           </p:cNvPr>
@@ -3701,12 +4082,48 @@
           </a:p>
         </p:txBody>
       </p:sp>
-      <p:sp>
-        <p:nvSpPr>
-          <p:cNvPr id="6" name="TextBox 5">
-            <a:extLst>
-              <a:ext uri="{FF2B5EF4-FFF2-40B4-BE49-F238E27FC236}">
-                <a16:creationId xmlns:a16="http://schemas.microsoft.com/office/drawing/2014/main" id="{92625059-4C85-C0C4-7F9F-EA1817AF8C16}"/>
+      <p:pic>
+        <p:nvPicPr>
+          <p:cNvPr id="55" name="Picture 54">
+            <a:extLst>
+              <a:ext uri="{FF2B5EF4-FFF2-40B4-BE49-F238E27FC236}">
+                <a16:creationId xmlns:a16="http://schemas.microsoft.com/office/drawing/2014/main" id="{FC9279A9-3F5E-4C1A-3C18-CE60FD667FB7}"/>
+              </a:ext>
+            </a:extLst>
+          </p:cNvPr>
+          <p:cNvPicPr>
+            <a:picLocks noChangeAspect="1"/>
+          </p:cNvPicPr>
+          <p:nvPr/>
+        </p:nvPicPr>
+        <p:blipFill>
+          <a:blip r:embed="rId2">
+            <a:extLst>
+              <a:ext uri="{28A0092B-C50C-407E-A947-70E740481C1C}">
+                <a14:useLocalDpi xmlns:a14="http://schemas.microsoft.com/office/drawing/2010/main" val="0"/>
+              </a:ext>
+            </a:extLst>
+          </a:blip>
+          <a:stretch>
+            <a:fillRect/>
+          </a:stretch>
+        </p:blipFill>
+        <p:spPr>
+          <a:xfrm>
+            <a:off x="711440" y="1834358"/>
+            <a:ext cx="4608730" cy="3401560"/>
+          </a:xfrm>
+          <a:prstGeom prst="rect">
+            <a:avLst/>
+          </a:prstGeom>
+        </p:spPr>
+      </p:pic>
+      <p:sp>
+        <p:nvSpPr>
+          <p:cNvPr id="2" name="TextBox 1">
+            <a:extLst>
+              <a:ext uri="{FF2B5EF4-FFF2-40B4-BE49-F238E27FC236}">
+                <a16:creationId xmlns:a16="http://schemas.microsoft.com/office/drawing/2014/main" id="{B3888715-AE2B-DB5F-83D9-104D375BE2C8}"/>
               </a:ext>
             </a:extLst>
           </p:cNvPr>
@@ -3715,8 +4132,147 @@
         </p:nvSpPr>
         <p:spPr>
           <a:xfrm>
-            <a:off x="89541" y="2967335"/>
-            <a:ext cx="1693539" cy="923330"/>
+            <a:off x="1851848" y="5402258"/>
+            <a:ext cx="2148345" cy="523220"/>
+          </a:xfrm>
+          <a:prstGeom prst="rect">
+            <a:avLst/>
+          </a:prstGeom>
+          <a:noFill/>
+        </p:spPr>
+        <p:txBody>
+          <a:bodyPr wrap="none" rtlCol="0">
+            <a:spAutoFit/>
+          </a:bodyPr>
+          <a:lstStyle/>
+          <a:p>
+            <a:r>
+              <a:rPr lang="en-US" sz="2800" dirty="0">
+                <a:latin typeface="Times New Roman" panose="02020603050405020304" pitchFamily="18" charset="0"/>
+                <a:cs typeface="Times New Roman" panose="02020603050405020304" pitchFamily="18" charset="0"/>
+              </a:rPr>
+              <a:t>Starting point</a:t>
+            </a:r>
+          </a:p>
+        </p:txBody>
+      </p:sp>
+      <p:sp>
+        <p:nvSpPr>
+          <p:cNvPr id="3" name="Rectangle: Rounded Corners 2">
+            <a:extLst>
+              <a:ext uri="{FF2B5EF4-FFF2-40B4-BE49-F238E27FC236}">
+                <a16:creationId xmlns:a16="http://schemas.microsoft.com/office/drawing/2014/main" id="{4B89558D-8DCE-1819-0DF3-B8780591612E}"/>
+              </a:ext>
+            </a:extLst>
+          </p:cNvPr>
+          <p:cNvSpPr/>
+          <p:nvPr/>
+        </p:nvSpPr>
+        <p:spPr>
+          <a:xfrm>
+            <a:off x="640080" y="1696637"/>
+            <a:ext cx="4850173" cy="3687139"/>
+          </a:xfrm>
+          <a:prstGeom prst="roundRect">
+            <a:avLst/>
+          </a:prstGeom>
+          <a:noFill/>
+          <a:ln w="57150" cap="flat" cmpd="sng" algn="ctr">
+            <a:solidFill>
+              <a:schemeClr val="dk1"/>
+            </a:solidFill>
+            <a:prstDash val="solid"/>
+            <a:round/>
+            <a:headEnd type="none" w="med" len="med"/>
+            <a:tailEnd type="none" w="med" len="med"/>
+          </a:ln>
+        </p:spPr>
+        <p:style>
+          <a:lnRef idx="0">
+            <a:scrgbClr r="0" g="0" b="0"/>
+          </a:lnRef>
+          <a:fillRef idx="0">
+            <a:scrgbClr r="0" g="0" b="0"/>
+          </a:fillRef>
+          <a:effectRef idx="0">
+            <a:scrgbClr r="0" g="0" b="0"/>
+          </a:effectRef>
+          <a:fontRef idx="minor">
+            <a:schemeClr val="dk1"/>
+          </a:fontRef>
+        </p:style>
+        <p:txBody>
+          <a:bodyPr rtlCol="0" anchor="ctr"/>
+          <a:lstStyle/>
+          <a:p>
+            <a:pPr algn="ctr"/>
+            <a:endParaRPr lang="en-US"/>
+          </a:p>
+        </p:txBody>
+      </p:sp>
+      <p:cxnSp>
+        <p:nvCxnSpPr>
+          <p:cNvPr id="8" name="Straight Arrow Connector 7">
+            <a:extLst>
+              <a:ext uri="{FF2B5EF4-FFF2-40B4-BE49-F238E27FC236}">
+                <a16:creationId xmlns:a16="http://schemas.microsoft.com/office/drawing/2014/main" id="{2B007ADB-659F-A154-6F86-79900B7ED942}"/>
+              </a:ext>
+            </a:extLst>
+          </p:cNvPr>
+          <p:cNvCxnSpPr>
+            <a:cxnSpLocks/>
+          </p:cNvCxnSpPr>
+          <p:nvPr/>
+        </p:nvCxnSpPr>
+        <p:spPr>
+          <a:xfrm>
+            <a:off x="5612500" y="4509585"/>
+            <a:ext cx="706004" cy="0"/>
+          </a:xfrm>
+          <a:prstGeom prst="straightConnector1">
+            <a:avLst/>
+          </a:prstGeom>
+          <a:ln w="57150" cap="flat" cmpd="sng" algn="ctr">
+            <a:solidFill>
+              <a:schemeClr val="accent1"/>
+            </a:solidFill>
+            <a:prstDash val="solid"/>
+            <a:round/>
+            <a:headEnd type="none" w="med" len="med"/>
+            <a:tailEnd type="arrow" w="med" len="med"/>
+          </a:ln>
+        </p:spPr>
+        <p:style>
+          <a:lnRef idx="0">
+            <a:scrgbClr r="0" g="0" b="0"/>
+          </a:lnRef>
+          <a:fillRef idx="0">
+            <a:scrgbClr r="0" g="0" b="0"/>
+          </a:fillRef>
+          <a:effectRef idx="0">
+            <a:scrgbClr r="0" g="0" b="0"/>
+          </a:effectRef>
+          <a:fontRef idx="minor">
+            <a:schemeClr val="tx1"/>
+          </a:fontRef>
+        </p:style>
+      </p:cxnSp>
+      <p:sp>
+        <p:nvSpPr>
+          <p:cNvPr id="17" name="TextBox 16">
+            <a:extLst>
+              <a:ext uri="{FF2B5EF4-FFF2-40B4-BE49-F238E27FC236}">
+                <a16:creationId xmlns:a16="http://schemas.microsoft.com/office/drawing/2014/main" id="{75CCC608-F474-1969-8AE1-2965F5E770C9}"/>
+              </a:ext>
+            </a:extLst>
+          </p:cNvPr>
+          <p:cNvSpPr txBox="1"/>
+          <p:nvPr/>
+        </p:nvSpPr>
+        <p:spPr>
+          <a:xfrm>
+            <a:off x="5953994" y="4702951"/>
+            <a:ext cx="1952619" cy="523220"/>
           </a:xfrm>
           <a:prstGeom prst="rect">
             <a:avLst/>
@@ -3770,123 +4326,31 @@
           <a:p>
             <a:pPr algn="ctr"/>
             <a:r>
-              <a:rPr lang="en-US" dirty="0">
+              <a:rPr lang="en-US" sz="1400" dirty="0">
                 <a:latin typeface="Times New Roman" panose="02020603050405020304" pitchFamily="18" charset="0"/>
                 <a:cs typeface="Times New Roman" panose="02020603050405020304" pitchFamily="18" charset="0"/>
               </a:rPr>
-              <a:t>PXRD data</a:t>
+              <a:t>Predicted CIF</a:t>
             </a:r>
           </a:p>
           <a:p>
             <a:pPr algn="ctr"/>
             <a:r>
-              <a:rPr lang="en-US" dirty="0">
+              <a:rPr lang="en-US" sz="1400" dirty="0">
                 <a:latin typeface="Times New Roman" panose="02020603050405020304" pitchFamily="18" charset="0"/>
                 <a:cs typeface="Times New Roman" panose="02020603050405020304" pitchFamily="18" charset="0"/>
               </a:rPr>
-              <a:t>2 column:</a:t>
-            </a:r>
-          </a:p>
-          <a:p>
-            <a:pPr algn="ctr"/>
-            <a:r>
-              <a:rPr lang="en-US" dirty="0">
-                <a:latin typeface="Times New Roman" panose="02020603050405020304" pitchFamily="18" charset="0"/>
-                <a:cs typeface="Times New Roman" panose="02020603050405020304" pitchFamily="18" charset="0"/>
-              </a:rPr>
-              <a:t>2theta, Intensity</a:t>
-            </a:r>
-          </a:p>
-        </p:txBody>
-      </p:sp>
-      <p:sp>
-        <p:nvSpPr>
-          <p:cNvPr id="7" name="TextBox 6">
-            <a:extLst>
-              <a:ext uri="{FF2B5EF4-FFF2-40B4-BE49-F238E27FC236}">
-                <a16:creationId xmlns:a16="http://schemas.microsoft.com/office/drawing/2014/main" id="{E18CEF72-6D4D-1BA0-ADAF-9D433ADE4C7E}"/>
-              </a:ext>
-            </a:extLst>
-          </p:cNvPr>
-          <p:cNvSpPr txBox="1"/>
-          <p:nvPr/>
-        </p:nvSpPr>
-        <p:spPr>
-          <a:xfrm>
-            <a:off x="2423841" y="3521333"/>
-            <a:ext cx="1456731" cy="369332"/>
-          </a:xfrm>
-          <a:prstGeom prst="rect">
-            <a:avLst/>
-          </a:prstGeom>
-          <a:gradFill flip="none" rotWithShape="1">
-            <a:gsLst>
-              <a:gs pos="0">
-                <a:schemeClr val="accent1">
-                  <a:lumMod val="67000"/>
-                </a:schemeClr>
-              </a:gs>
-              <a:gs pos="48000">
-                <a:schemeClr val="accent1">
-                  <a:lumMod val="97000"/>
-                  <a:lumOff val="3000"/>
-                </a:schemeClr>
-              </a:gs>
-              <a:gs pos="100000">
-                <a:schemeClr val="accent1">
-                  <a:lumMod val="60000"/>
-                  <a:lumOff val="40000"/>
-                </a:schemeClr>
-              </a:gs>
-            </a:gsLst>
-            <a:lin ang="16200000" scaled="1"/>
-            <a:tileRect/>
-          </a:gradFill>
-          <a:ln>
-            <a:noFill/>
-          </a:ln>
-        </p:spPr>
-        <p:style>
-          <a:lnRef idx="0">
-            <a:scrgbClr r="0" g="0" b="0"/>
-          </a:lnRef>
-          <a:fillRef idx="0">
-            <a:scrgbClr r="0" g="0" b="0"/>
-          </a:fillRef>
-          <a:effectRef idx="0">
-            <a:scrgbClr r="0" g="0" b="0"/>
-          </a:effectRef>
-          <a:fontRef idx="minor">
-            <a:schemeClr val="lt1"/>
-          </a:fontRef>
-        </p:style>
-        <p:txBody>
-          <a:bodyPr wrap="square" rtlCol="0">
-            <a:spAutoFit/>
-          </a:bodyPr>
-          <a:lstStyle/>
-          <a:p>
-            <a:pPr algn="ctr"/>
-            <a:r>
-              <a:rPr lang="en-US" dirty="0" err="1">
-                <a:latin typeface="Times New Roman" panose="02020603050405020304" pitchFamily="18" charset="0"/>
-                <a:cs typeface="Times New Roman" panose="02020603050405020304" pitchFamily="18" charset="0"/>
-              </a:rPr>
-              <a:t>DiffractGPT</a:t>
-            </a:r>
-            <a:endParaRPr lang="en-US" dirty="0">
-              <a:latin typeface="Times New Roman" panose="02020603050405020304" pitchFamily="18" charset="0"/>
-              <a:cs typeface="Times New Roman" panose="02020603050405020304" pitchFamily="18" charset="0"/>
-            </a:endParaRPr>
+              <a:t>Without Symmetry (P1)</a:t>
+            </a:r>
           </a:p>
         </p:txBody>
       </p:sp>
       <p:pic>
         <p:nvPicPr>
-          <p:cNvPr id="9" name="Graphic 8" descr="Robot with solid fill">
-            <a:extLst>
-              <a:ext uri="{FF2B5EF4-FFF2-40B4-BE49-F238E27FC236}">
-                <a16:creationId xmlns:a16="http://schemas.microsoft.com/office/drawing/2014/main" id="{8F7A4733-D45F-85A5-C149-AF0960CB4D8B}"/>
+          <p:cNvPr id="21" name="Graphic 20" descr="Document with solid fill">
+            <a:extLst>
+              <a:ext uri="{FF2B5EF4-FFF2-40B4-BE49-F238E27FC236}">
+                <a16:creationId xmlns:a16="http://schemas.microsoft.com/office/drawing/2014/main" id="{1ADA9D8D-F949-F58F-6B92-FD80ABA07DFE}"/>
               </a:ext>
             </a:extLst>
           </p:cNvPr>
@@ -3896,10 +4360,10 @@
           <p:nvPr/>
         </p:nvPicPr>
         <p:blipFill>
-          <a:blip r:embed="rId2">
+          <a:blip r:embed="rId3">
             <a:extLst>
               <a:ext uri="{96DAC541-7B7A-43D3-8B79-37D633B846F1}">
-                <asvg:svgBlip xmlns:asvg="http://schemas.microsoft.com/office/drawing/2016/SVG/main" r:embed="rId3"/>
+                <asvg:svgBlip xmlns:asvg="http://schemas.microsoft.com/office/drawing/2016/SVG/main" r:embed="rId4"/>
               </a:ext>
             </a:extLst>
           </a:blip>
@@ -3909,8 +4373,8 @@
         </p:blipFill>
         <p:spPr>
           <a:xfrm>
-            <a:off x="2695006" y="2606933"/>
-            <a:ext cx="914400" cy="914400"/>
+            <a:off x="6575786" y="4087255"/>
+            <a:ext cx="615696" cy="615696"/>
           </a:xfrm>
           <a:prstGeom prst="rect">
             <a:avLst/>
@@ -3919,10 +4383,10 @@
       </p:pic>
       <p:sp>
         <p:nvSpPr>
-          <p:cNvPr id="10" name="TextBox 9">
-            <a:extLst>
-              <a:ext uri="{FF2B5EF4-FFF2-40B4-BE49-F238E27FC236}">
-                <a16:creationId xmlns:a16="http://schemas.microsoft.com/office/drawing/2014/main" id="{F57B27B2-37DF-1395-7AC8-878B5DC595E9}"/>
+          <p:cNvPr id="22" name="TextBox 21">
+            <a:extLst>
+              <a:ext uri="{FF2B5EF4-FFF2-40B4-BE49-F238E27FC236}">
+                <a16:creationId xmlns:a16="http://schemas.microsoft.com/office/drawing/2014/main" id="{42C2EE16-0D47-46BC-0FCB-78BA564AB2E6}"/>
               </a:ext>
             </a:extLst>
           </p:cNvPr>
@@ -3931,95 +4395,7 @@
         </p:nvSpPr>
         <p:spPr>
           <a:xfrm>
-            <a:off x="4521332" y="2967335"/>
-            <a:ext cx="1952619" cy="923330"/>
-          </a:xfrm>
-          <a:prstGeom prst="rect">
-            <a:avLst/>
-          </a:prstGeom>
-          <a:gradFill flip="none" rotWithShape="1">
-            <a:gsLst>
-              <a:gs pos="0">
-                <a:schemeClr val="dk1">
-                  <a:lumMod val="67000"/>
-                </a:schemeClr>
-              </a:gs>
-              <a:gs pos="48000">
-                <a:schemeClr val="dk1">
-                  <a:lumMod val="97000"/>
-                  <a:lumOff val="3000"/>
-                </a:schemeClr>
-              </a:gs>
-              <a:gs pos="100000">
-                <a:schemeClr val="dk1">
-                  <a:lumMod val="60000"/>
-                  <a:lumOff val="40000"/>
-                </a:schemeClr>
-              </a:gs>
-            </a:gsLst>
-            <a:lin ang="16200000" scaled="1"/>
-            <a:tileRect/>
-          </a:gradFill>
-          <a:ln>
-            <a:noFill/>
-          </a:ln>
-        </p:spPr>
-        <p:style>
-          <a:lnRef idx="0">
-            <a:scrgbClr r="0" g="0" b="0"/>
-          </a:lnRef>
-          <a:fillRef idx="0">
-            <a:scrgbClr r="0" g="0" b="0"/>
-          </a:fillRef>
-          <a:effectRef idx="0">
-            <a:scrgbClr r="0" g="0" b="0"/>
-          </a:effectRef>
-          <a:fontRef idx="minor">
-            <a:schemeClr val="lt1"/>
-          </a:fontRef>
-        </p:style>
-        <p:txBody>
-          <a:bodyPr wrap="square" rtlCol="0">
-            <a:spAutoFit/>
-          </a:bodyPr>
-          <a:lstStyle/>
-          <a:p>
-            <a:pPr algn="ctr"/>
-            <a:r>
-              <a:rPr lang="en-US" dirty="0">
-                <a:latin typeface="Times New Roman" panose="02020603050405020304" pitchFamily="18" charset="0"/>
-                <a:cs typeface="Times New Roman" panose="02020603050405020304" pitchFamily="18" charset="0"/>
-              </a:rPr>
-              <a:t>Predicted CIF</a:t>
-            </a:r>
-          </a:p>
-          <a:p>
-            <a:pPr algn="ctr"/>
-            <a:r>
-              <a:rPr lang="en-US" dirty="0">
-                <a:latin typeface="Times New Roman" panose="02020603050405020304" pitchFamily="18" charset="0"/>
-                <a:cs typeface="Times New Roman" panose="02020603050405020304" pitchFamily="18" charset="0"/>
-              </a:rPr>
-              <a:t>Without Symmetry (P1)</a:t>
-            </a:r>
-          </a:p>
-        </p:txBody>
-      </p:sp>
-      <p:sp>
-        <p:nvSpPr>
-          <p:cNvPr id="11" name="TextBox 10">
-            <a:extLst>
-              <a:ext uri="{FF2B5EF4-FFF2-40B4-BE49-F238E27FC236}">
-                <a16:creationId xmlns:a16="http://schemas.microsoft.com/office/drawing/2014/main" id="{0A3537F3-72DF-B1BD-0E65-9DF9F51D124D}"/>
-              </a:ext>
-            </a:extLst>
-          </p:cNvPr>
-          <p:cNvSpPr txBox="1"/>
-          <p:nvPr/>
-        </p:nvSpPr>
-        <p:spPr>
-          <a:xfrm>
-            <a:off x="7718215" y="3326630"/>
+            <a:off x="8434257" y="4346385"/>
             <a:ext cx="1316057" cy="369332"/>
           </a:xfrm>
           <a:prstGeom prst="rect">
@@ -4086,100 +4462,10 @@
       </p:sp>
       <p:cxnSp>
         <p:nvCxnSpPr>
-          <p:cNvPr id="13" name="Straight Arrow Connector 12">
-            <a:extLst>
-              <a:ext uri="{FF2B5EF4-FFF2-40B4-BE49-F238E27FC236}">
-                <a16:creationId xmlns:a16="http://schemas.microsoft.com/office/drawing/2014/main" id="{D75C5B89-A0D0-AF14-7DF9-C216F973B423}"/>
-              </a:ext>
-            </a:extLst>
-          </p:cNvPr>
-          <p:cNvCxnSpPr/>
-          <p:nvPr/>
-        </p:nvCxnSpPr>
-        <p:spPr>
-          <a:xfrm>
-            <a:off x="1938528" y="3521333"/>
-            <a:ext cx="329184" cy="0"/>
-          </a:xfrm>
-          <a:prstGeom prst="straightConnector1">
-            <a:avLst/>
-          </a:prstGeom>
-          <a:ln w="57150" cap="flat" cmpd="sng" algn="ctr">
-            <a:solidFill>
-              <a:schemeClr val="accent1"/>
-            </a:solidFill>
-            <a:prstDash val="solid"/>
-            <a:round/>
-            <a:headEnd type="none" w="med" len="med"/>
-            <a:tailEnd type="arrow" w="med" len="med"/>
-          </a:ln>
-        </p:spPr>
-        <p:style>
-          <a:lnRef idx="0">
-            <a:scrgbClr r="0" g="0" b="0"/>
-          </a:lnRef>
-          <a:fillRef idx="0">
-            <a:scrgbClr r="0" g="0" b="0"/>
-          </a:fillRef>
-          <a:effectRef idx="0">
-            <a:scrgbClr r="0" g="0" b="0"/>
-          </a:effectRef>
-          <a:fontRef idx="minor">
-            <a:schemeClr val="tx1"/>
-          </a:fontRef>
-        </p:style>
-      </p:cxnSp>
-      <p:cxnSp>
-        <p:nvCxnSpPr>
-          <p:cNvPr id="14" name="Straight Arrow Connector 13">
-            <a:extLst>
-              <a:ext uri="{FF2B5EF4-FFF2-40B4-BE49-F238E27FC236}">
-                <a16:creationId xmlns:a16="http://schemas.microsoft.com/office/drawing/2014/main" id="{96F69E6B-A9F0-758A-409A-E9924FC6DA0A}"/>
-              </a:ext>
-            </a:extLst>
-          </p:cNvPr>
-          <p:cNvCxnSpPr/>
-          <p:nvPr/>
-        </p:nvCxnSpPr>
-        <p:spPr>
-          <a:xfrm>
-            <a:off x="4020312" y="3521333"/>
-            <a:ext cx="329184" cy="0"/>
-          </a:xfrm>
-          <a:prstGeom prst="straightConnector1">
-            <a:avLst/>
-          </a:prstGeom>
-          <a:ln w="57150" cap="flat" cmpd="sng" algn="ctr">
-            <a:solidFill>
-              <a:schemeClr val="accent1"/>
-            </a:solidFill>
-            <a:prstDash val="solid"/>
-            <a:round/>
-            <a:headEnd type="none" w="med" len="med"/>
-            <a:tailEnd type="arrow" w="med" len="med"/>
-          </a:ln>
-        </p:spPr>
-        <p:style>
-          <a:lnRef idx="0">
-            <a:scrgbClr r="0" g="0" b="0"/>
-          </a:lnRef>
-          <a:fillRef idx="0">
-            <a:scrgbClr r="0" g="0" b="0"/>
-          </a:fillRef>
-          <a:effectRef idx="0">
-            <a:scrgbClr r="0" g="0" b="0"/>
-          </a:effectRef>
-          <a:fontRef idx="minor">
-            <a:schemeClr val="tx1"/>
-          </a:fontRef>
-        </p:style>
-      </p:cxnSp>
-      <p:cxnSp>
-        <p:nvCxnSpPr>
-          <p:cNvPr id="15" name="Straight Arrow Connector 14">
-            <a:extLst>
-              <a:ext uri="{FF2B5EF4-FFF2-40B4-BE49-F238E27FC236}">
-                <a16:creationId xmlns:a16="http://schemas.microsoft.com/office/drawing/2014/main" id="{BA0BFC53-8C85-AFD0-02A7-A8CFCD3C2920}"/>
+          <p:cNvPr id="26" name="Straight Arrow Connector 25">
+            <a:extLst>
+              <a:ext uri="{FF2B5EF4-FFF2-40B4-BE49-F238E27FC236}">
+                <a16:creationId xmlns:a16="http://schemas.microsoft.com/office/drawing/2014/main" id="{583F366C-2102-77F0-89F2-08EF688C3367}"/>
               </a:ext>
             </a:extLst>
           </p:cNvPr>
@@ -4190,7 +4476,7 @@
         </p:nvCxnSpPr>
         <p:spPr>
           <a:xfrm>
-            <a:off x="6650736" y="3521333"/>
+            <a:off x="7305818" y="4518288"/>
             <a:ext cx="947928" cy="0"/>
           </a:xfrm>
           <a:prstGeom prst="straightConnector1">
@@ -4221,93 +4507,21 @@
           </a:fontRef>
         </p:style>
       </p:cxnSp>
-      <p:pic>
-        <p:nvPicPr>
-          <p:cNvPr id="18" name="Graphic 17" descr="Document with solid fill">
-            <a:extLst>
-              <a:ext uri="{FF2B5EF4-FFF2-40B4-BE49-F238E27FC236}">
-                <a16:creationId xmlns:a16="http://schemas.microsoft.com/office/drawing/2014/main" id="{ECEC862B-538C-ACE0-27C7-C7E9893C0D04}"/>
-              </a:ext>
-            </a:extLst>
-          </p:cNvPr>
-          <p:cNvPicPr>
-            <a:picLocks noChangeAspect="1"/>
-          </p:cNvPicPr>
+      <p:sp>
+        <p:nvSpPr>
+          <p:cNvPr id="28" name="TextBox 27">
+            <a:extLst>
+              <a:ext uri="{FF2B5EF4-FFF2-40B4-BE49-F238E27FC236}">
+                <a16:creationId xmlns:a16="http://schemas.microsoft.com/office/drawing/2014/main" id="{2EC9EAB1-42C3-B9BA-A64C-92E9CAF2506A}"/>
+              </a:ext>
+            </a:extLst>
+          </p:cNvPr>
+          <p:cNvSpPr txBox="1"/>
           <p:nvPr/>
-        </p:nvPicPr>
-        <p:blipFill>
-          <a:blip r:embed="rId4">
-            <a:extLst>
-              <a:ext uri="{96DAC541-7B7A-43D3-8B79-37D633B846F1}">
-                <asvg:svgBlip xmlns:asvg="http://schemas.microsoft.com/office/drawing/2016/SVG/main" r:embed="rId5"/>
-              </a:ext>
-            </a:extLst>
-          </a:blip>
-          <a:stretch>
-            <a:fillRect/>
-          </a:stretch>
-        </p:blipFill>
+        </p:nvSpPr>
         <p:spPr>
           <a:xfrm>
-            <a:off x="628462" y="2351639"/>
-            <a:ext cx="615696" cy="615696"/>
-          </a:xfrm>
-          <a:prstGeom prst="rect">
-            <a:avLst/>
-          </a:prstGeom>
-        </p:spPr>
-      </p:pic>
-      <p:pic>
-        <p:nvPicPr>
-          <p:cNvPr id="19" name="Graphic 18" descr="Document with solid fill">
-            <a:extLst>
-              <a:ext uri="{FF2B5EF4-FFF2-40B4-BE49-F238E27FC236}">
-                <a16:creationId xmlns:a16="http://schemas.microsoft.com/office/drawing/2014/main" id="{FCE80453-BE55-22F3-B0D2-E0B7EF0A6444}"/>
-              </a:ext>
-            </a:extLst>
-          </p:cNvPr>
-          <p:cNvPicPr>
-            <a:picLocks noChangeAspect="1"/>
-          </p:cNvPicPr>
-          <p:nvPr/>
-        </p:nvPicPr>
-        <p:blipFill>
-          <a:blip r:embed="rId4">
-            <a:extLst>
-              <a:ext uri="{96DAC541-7B7A-43D3-8B79-37D633B846F1}">
-                <asvg:svgBlip xmlns:asvg="http://schemas.microsoft.com/office/drawing/2016/SVG/main" r:embed="rId5"/>
-              </a:ext>
-            </a:extLst>
-          </a:blip>
-          <a:stretch>
-            <a:fillRect/>
-          </a:stretch>
-        </p:blipFill>
-        <p:spPr>
-          <a:xfrm>
-            <a:off x="5143124" y="2351639"/>
-            <a:ext cx="615696" cy="615696"/>
-          </a:xfrm>
-          <a:prstGeom prst="rect">
-            <a:avLst/>
-          </a:prstGeom>
-        </p:spPr>
-      </p:pic>
-      <p:sp>
-        <p:nvSpPr>
-          <p:cNvPr id="20" name="TextBox 19">
-            <a:extLst>
-              <a:ext uri="{FF2B5EF4-FFF2-40B4-BE49-F238E27FC236}">
-                <a16:creationId xmlns:a16="http://schemas.microsoft.com/office/drawing/2014/main" id="{9D0648B9-5945-BF27-E79D-CF40A9EF90CA}"/>
-              </a:ext>
-            </a:extLst>
-          </p:cNvPr>
-          <p:cNvSpPr txBox="1"/>
-          <p:nvPr/>
-        </p:nvSpPr>
-        <p:spPr>
-          <a:xfrm>
-            <a:off x="6769519" y="3107174"/>
+            <a:off x="7486710" y="3977053"/>
             <a:ext cx="653128" cy="369332"/>
           </a:xfrm>
           <a:prstGeom prst="rect">
@@ -4330,10 +4544,10 @@
       </p:sp>
       <p:sp>
         <p:nvSpPr>
-          <p:cNvPr id="23" name="Multiplication Sign 22">
-            <a:extLst>
-              <a:ext uri="{FF2B5EF4-FFF2-40B4-BE49-F238E27FC236}">
-                <a16:creationId xmlns:a16="http://schemas.microsoft.com/office/drawing/2014/main" id="{3DAE33E9-F498-323E-34D2-9FC8A43CF4EF}"/>
+          <p:cNvPr id="32" name="Multiplication Sign 31">
+            <a:extLst>
+              <a:ext uri="{FF2B5EF4-FFF2-40B4-BE49-F238E27FC236}">
+                <a16:creationId xmlns:a16="http://schemas.microsoft.com/office/drawing/2014/main" id="{ECF9F37E-58D7-03F4-2A82-398D3CC1A4C7}"/>
               </a:ext>
             </a:extLst>
           </p:cNvPr>
@@ -4342,7 +4556,7 @@
         </p:nvSpPr>
         <p:spPr>
           <a:xfrm>
-            <a:off x="6940635" y="3336669"/>
+            <a:off x="7595717" y="4333624"/>
             <a:ext cx="310896" cy="369327"/>
           </a:xfrm>
           <a:prstGeom prst="mathMultiply">
@@ -4374,12 +4588,42 @@
           </a:p>
         </p:txBody>
       </p:sp>
-      <p:sp>
-        <p:nvSpPr>
-          <p:cNvPr id="24" name="TextBox 23">
-            <a:extLst>
-              <a:ext uri="{FF2B5EF4-FFF2-40B4-BE49-F238E27FC236}">
-                <a16:creationId xmlns:a16="http://schemas.microsoft.com/office/drawing/2014/main" id="{9393FC90-CE5F-347E-6638-E5387A6C5481}"/>
+      <p:pic>
+        <p:nvPicPr>
+          <p:cNvPr id="34" name="Picture 33">
+            <a:extLst>
+              <a:ext uri="{FF2B5EF4-FFF2-40B4-BE49-F238E27FC236}">
+                <a16:creationId xmlns:a16="http://schemas.microsoft.com/office/drawing/2014/main" id="{4E42EBD3-4C75-15E0-CE4B-A10868E2491B}"/>
+              </a:ext>
+            </a:extLst>
+          </p:cNvPr>
+          <p:cNvPicPr>
+            <a:picLocks noChangeAspect="1"/>
+          </p:cNvPicPr>
+          <p:nvPr/>
+        </p:nvPicPr>
+        <p:blipFill>
+          <a:blip r:embed="rId5"/>
+          <a:stretch>
+            <a:fillRect/>
+          </a:stretch>
+        </p:blipFill>
+        <p:spPr>
+          <a:xfrm>
+            <a:off x="9825304" y="3783252"/>
+            <a:ext cx="1860249" cy="1452666"/>
+          </a:xfrm>
+          <a:prstGeom prst="rect">
+            <a:avLst/>
+          </a:prstGeom>
+        </p:spPr>
+      </p:pic>
+      <p:sp>
+        <p:nvSpPr>
+          <p:cNvPr id="35" name="TextBox 34">
+            <a:extLst>
+              <a:ext uri="{FF2B5EF4-FFF2-40B4-BE49-F238E27FC236}">
+                <a16:creationId xmlns:a16="http://schemas.microsoft.com/office/drawing/2014/main" id="{B2C32301-3DB9-DB28-015D-9AEFEDAA2AE4}"/>
               </a:ext>
             </a:extLst>
           </p:cNvPr>
@@ -4387,8 +4631,57 @@
           <p:nvPr/>
         </p:nvSpPr>
         <p:spPr>
+          <a:xfrm rot="10800000" flipH="1" flipV="1">
+            <a:off x="8728363" y="5340702"/>
+            <a:ext cx="2634533" cy="646331"/>
+          </a:xfrm>
+          <a:prstGeom prst="rect">
+            <a:avLst/>
+          </a:prstGeom>
+          <a:noFill/>
+        </p:spPr>
+        <p:txBody>
+          <a:bodyPr wrap="square" rtlCol="0">
+            <a:spAutoFit/>
+          </a:bodyPr>
+          <a:lstStyle/>
+          <a:p>
+            <a:pPr marL="285750" indent="-285750">
+              <a:buFont typeface="Arial" panose="020B0604020202020204" pitchFamily="34" charset="0"/>
+              <a:buChar char="•"/>
+            </a:pPr>
+            <a:r>
+              <a:rPr lang="en-US" dirty="0"/>
+              <a:t>Lattice parameters</a:t>
+            </a:r>
+          </a:p>
+          <a:p>
+            <a:pPr marL="285750" indent="-285750">
+              <a:buFont typeface="Arial" panose="020B0604020202020204" pitchFamily="34" charset="0"/>
+              <a:buChar char="•"/>
+            </a:pPr>
+            <a:r>
+              <a:rPr lang="en-US" dirty="0"/>
+              <a:t>Chi2</a:t>
+            </a:r>
+          </a:p>
+        </p:txBody>
+      </p:sp>
+      <p:sp>
+        <p:nvSpPr>
+          <p:cNvPr id="37" name="TextBox 36">
+            <a:extLst>
+              <a:ext uri="{FF2B5EF4-FFF2-40B4-BE49-F238E27FC236}">
+                <a16:creationId xmlns:a16="http://schemas.microsoft.com/office/drawing/2014/main" id="{DE0BEFA4-B1B6-D889-6003-BD6CE1F04782}"/>
+              </a:ext>
+            </a:extLst>
+          </p:cNvPr>
+          <p:cNvSpPr txBox="1"/>
+          <p:nvPr/>
+        </p:nvSpPr>
+        <p:spPr>
           <a:xfrm>
-            <a:off x="4839612" y="1220326"/>
+            <a:off x="6016796" y="3102237"/>
             <a:ext cx="1316057" cy="369332"/>
           </a:xfrm>
           <a:prstGeom prst="rect">
@@ -4459,10 +4752,10 @@
       </p:sp>
       <p:cxnSp>
         <p:nvCxnSpPr>
-          <p:cNvPr id="25" name="Straight Arrow Connector 24">
-            <a:extLst>
-              <a:ext uri="{FF2B5EF4-FFF2-40B4-BE49-F238E27FC236}">
-                <a16:creationId xmlns:a16="http://schemas.microsoft.com/office/drawing/2014/main" id="{161C4ACA-02EC-D106-C546-8790EA1D5669}"/>
+          <p:cNvPr id="38" name="Straight Arrow Connector 37">
+            <a:extLst>
+              <a:ext uri="{FF2B5EF4-FFF2-40B4-BE49-F238E27FC236}">
+                <a16:creationId xmlns:a16="http://schemas.microsoft.com/office/drawing/2014/main" id="{047A3B81-746A-22E6-AB0D-F6F8D9092E31}"/>
               </a:ext>
             </a:extLst>
           </p:cNvPr>
@@ -4473,8 +4766,8 @@
         </p:nvCxnSpPr>
         <p:spPr>
           <a:xfrm flipV="1">
-            <a:off x="5437828" y="1719072"/>
-            <a:ext cx="0" cy="537341"/>
+            <a:off x="6812578" y="3662715"/>
+            <a:ext cx="0" cy="398819"/>
           </a:xfrm>
           <a:prstGeom prst="straightConnector1">
             <a:avLst/>
@@ -4506,10 +4799,10 @@
       </p:cxnSp>
       <p:cxnSp>
         <p:nvCxnSpPr>
-          <p:cNvPr id="27" name="Straight Arrow Connector 26">
-            <a:extLst>
-              <a:ext uri="{FF2B5EF4-FFF2-40B4-BE49-F238E27FC236}">
-                <a16:creationId xmlns:a16="http://schemas.microsoft.com/office/drawing/2014/main" id="{8F10DBFE-C1DD-8184-9162-B25A93D43B0B}"/>
+          <p:cNvPr id="40" name="Straight Arrow Connector 39">
+            <a:extLst>
+              <a:ext uri="{FF2B5EF4-FFF2-40B4-BE49-F238E27FC236}">
+                <a16:creationId xmlns:a16="http://schemas.microsoft.com/office/drawing/2014/main" id="{42769015-40F4-4FED-D0C7-50B536386FC6}"/>
               </a:ext>
             </a:extLst>
           </p:cNvPr>
@@ -4520,8 +4813,8 @@
         </p:nvCxnSpPr>
         <p:spPr>
           <a:xfrm>
-            <a:off x="6285172" y="1404992"/>
-            <a:ext cx="1313492" cy="0"/>
+            <a:off x="7402318" y="3275972"/>
+            <a:ext cx="386798" cy="0"/>
           </a:xfrm>
           <a:prstGeom prst="straightConnector1">
             <a:avLst/>
@@ -4553,10 +4846,10 @@
       </p:cxnSp>
       <p:sp>
         <p:nvSpPr>
-          <p:cNvPr id="29" name="TextBox 28">
-            <a:extLst>
-              <a:ext uri="{FF2B5EF4-FFF2-40B4-BE49-F238E27FC236}">
-                <a16:creationId xmlns:a16="http://schemas.microsoft.com/office/drawing/2014/main" id="{BD65C78F-D6D4-F8B1-183B-E5DC2231A098}"/>
+          <p:cNvPr id="41" name="TextBox 40">
+            <a:extLst>
+              <a:ext uri="{FF2B5EF4-FFF2-40B4-BE49-F238E27FC236}">
+                <a16:creationId xmlns:a16="http://schemas.microsoft.com/office/drawing/2014/main" id="{A1B95DCA-0DA6-3573-52DF-0B909CEBC1B8}"/>
               </a:ext>
             </a:extLst>
           </p:cNvPr>
@@ -4565,8 +4858,8 @@
         </p:nvSpPr>
         <p:spPr>
           <a:xfrm>
-            <a:off x="7251531" y="1652783"/>
-            <a:ext cx="1952619" cy="646331"/>
+            <a:off x="7872676" y="3033993"/>
+            <a:ext cx="1529388" cy="523220"/>
           </a:xfrm>
           <a:prstGeom prst="rect">
             <a:avLst/>
@@ -4620,7 +4913,7 @@
           <a:p>
             <a:pPr algn="ctr"/>
             <a:r>
-              <a:rPr lang="en-US" dirty="0">
+              <a:rPr lang="en-US" sz="1400" dirty="0">
                 <a:latin typeface="Times New Roman" panose="02020603050405020304" pitchFamily="18" charset="0"/>
                 <a:cs typeface="Times New Roman" panose="02020603050405020304" pitchFamily="18" charset="0"/>
               </a:rPr>
@@ -4630,7 +4923,7 @@
           <a:p>
             <a:pPr algn="ctr"/>
             <a:r>
-              <a:rPr lang="en-US" dirty="0">
+              <a:rPr lang="en-US" sz="1400" dirty="0">
                 <a:latin typeface="Times New Roman" panose="02020603050405020304" pitchFamily="18" charset="0"/>
                 <a:cs typeface="Times New Roman" panose="02020603050405020304" pitchFamily="18" charset="0"/>
               </a:rPr>
@@ -4639,48 +4932,12 @@
           </a:p>
         </p:txBody>
       </p:sp>
-      <p:pic>
-        <p:nvPicPr>
-          <p:cNvPr id="30" name="Graphic 29" descr="Document with solid fill">
-            <a:extLst>
-              <a:ext uri="{FF2B5EF4-FFF2-40B4-BE49-F238E27FC236}">
-                <a16:creationId xmlns:a16="http://schemas.microsoft.com/office/drawing/2014/main" id="{812F593D-EEC3-4C0C-F852-7C4C4185F195}"/>
-              </a:ext>
-            </a:extLst>
-          </p:cNvPr>
-          <p:cNvPicPr>
-            <a:picLocks noChangeAspect="1"/>
-          </p:cNvPicPr>
-          <p:nvPr/>
-        </p:nvPicPr>
-        <p:blipFill>
-          <a:blip r:embed="rId4">
-            <a:extLst>
-              <a:ext uri="{96DAC541-7B7A-43D3-8B79-37D633B846F1}">
-                <asvg:svgBlip xmlns:asvg="http://schemas.microsoft.com/office/drawing/2016/SVG/main" r:embed="rId5"/>
-              </a:ext>
-            </a:extLst>
-          </a:blip>
-          <a:stretch>
-            <a:fillRect/>
-          </a:stretch>
-        </p:blipFill>
-        <p:spPr>
-          <a:xfrm>
-            <a:off x="7969371" y="1037087"/>
-            <a:ext cx="615696" cy="615696"/>
-          </a:xfrm>
-          <a:prstGeom prst="rect">
-            <a:avLst/>
-          </a:prstGeom>
-        </p:spPr>
-      </p:pic>
       <p:cxnSp>
         <p:nvCxnSpPr>
-          <p:cNvPr id="31" name="Straight Arrow Connector 30">
-            <a:extLst>
-              <a:ext uri="{FF2B5EF4-FFF2-40B4-BE49-F238E27FC236}">
-                <a16:creationId xmlns:a16="http://schemas.microsoft.com/office/drawing/2014/main" id="{C4B43BAD-7379-9672-429C-9F9696E924C9}"/>
+          <p:cNvPr id="45" name="Straight Arrow Connector 44">
+            <a:extLst>
+              <a:ext uri="{FF2B5EF4-FFF2-40B4-BE49-F238E27FC236}">
+                <a16:creationId xmlns:a16="http://schemas.microsoft.com/office/drawing/2014/main" id="{B1FDC02B-F52B-48C1-7575-E26F701EEA55}"/>
               </a:ext>
             </a:extLst>
           </p:cNvPr>
@@ -4691,8 +4948,90 @@
         </p:nvCxnSpPr>
         <p:spPr>
           <a:xfrm flipH="1">
-            <a:off x="8277219" y="2351639"/>
-            <a:ext cx="17478" cy="755535"/>
+            <a:off x="9101434" y="3783167"/>
+            <a:ext cx="8739" cy="510826"/>
+          </a:xfrm>
+          <a:prstGeom prst="straightConnector1">
+            <a:avLst/>
+          </a:prstGeom>
+          <a:ln w="57150" cap="flat" cmpd="sng" algn="ctr">
+            <a:solidFill>
+              <a:schemeClr val="accent1"/>
+            </a:solidFill>
+            <a:prstDash val="solid"/>
+            <a:round/>
+            <a:headEnd type="none" w="med" len="med"/>
+            <a:tailEnd type="arrow" w="med" len="med"/>
+          </a:ln>
+        </p:spPr>
+        <p:style>
+          <a:lnRef idx="0">
+            <a:scrgbClr r="0" g="0" b="0"/>
+          </a:lnRef>
+          <a:fillRef idx="0">
+            <a:scrgbClr r="0" g="0" b="0"/>
+          </a:fillRef>
+          <a:effectRef idx="0">
+            <a:scrgbClr r="0" g="0" b="0"/>
+          </a:effectRef>
+          <a:fontRef idx="minor">
+            <a:schemeClr val="tx1"/>
+          </a:fontRef>
+        </p:style>
+      </p:cxnSp>
+      <p:sp>
+        <p:nvSpPr>
+          <p:cNvPr id="47" name="TextBox 46">
+            <a:extLst>
+              <a:ext uri="{FF2B5EF4-FFF2-40B4-BE49-F238E27FC236}">
+                <a16:creationId xmlns:a16="http://schemas.microsoft.com/office/drawing/2014/main" id="{4DD67034-12EC-B126-1918-86B9C3D6C8DB}"/>
+              </a:ext>
+            </a:extLst>
+          </p:cNvPr>
+          <p:cNvSpPr txBox="1"/>
+          <p:nvPr/>
+        </p:nvSpPr>
+        <p:spPr>
+          <a:xfrm>
+            <a:off x="5994157" y="2040150"/>
+            <a:ext cx="3203120" cy="923330"/>
+          </a:xfrm>
+          <a:prstGeom prst="rect">
+            <a:avLst/>
+          </a:prstGeom>
+          <a:noFill/>
+        </p:spPr>
+        <p:txBody>
+          <a:bodyPr wrap="square" rtlCol="0">
+            <a:spAutoFit/>
+          </a:bodyPr>
+          <a:lstStyle/>
+          <a:p>
+            <a:r>
+              <a:rPr lang="en-US" dirty="0"/>
+              <a:t>Not sure if it’s always necessary, but GSAS kept failing when refining the P1 CIF</a:t>
+            </a:r>
+          </a:p>
+        </p:txBody>
+      </p:sp>
+      <p:cxnSp>
+        <p:nvCxnSpPr>
+          <p:cNvPr id="57" name="Straight Arrow Connector 56">
+            <a:extLst>
+              <a:ext uri="{FF2B5EF4-FFF2-40B4-BE49-F238E27FC236}">
+                <a16:creationId xmlns:a16="http://schemas.microsoft.com/office/drawing/2014/main" id="{D2C9358E-6560-60E3-F78D-E9C0103E77A8}"/>
+              </a:ext>
+            </a:extLst>
+          </p:cNvPr>
+          <p:cNvCxnSpPr>
+            <a:cxnSpLocks/>
+          </p:cNvCxnSpPr>
+          <p:nvPr/>
+        </p:nvCxnSpPr>
+        <p:spPr>
+          <a:xfrm flipH="1">
+            <a:off x="9646482" y="1367018"/>
+            <a:ext cx="8739" cy="2949929"/>
           </a:xfrm>
           <a:prstGeom prst="straightConnector1">
             <a:avLst/>
@@ -4724,10 +5063,10 @@
       </p:cxnSp>
       <p:cxnSp>
         <p:nvCxnSpPr>
-          <p:cNvPr id="39" name="Straight Arrow Connector 38">
-            <a:extLst>
-              <a:ext uri="{FF2B5EF4-FFF2-40B4-BE49-F238E27FC236}">
-                <a16:creationId xmlns:a16="http://schemas.microsoft.com/office/drawing/2014/main" id="{E37BF77A-B398-BEDB-6C02-6BDF6AA9E93E}"/>
+          <p:cNvPr id="59" name="Straight Connector 58">
+            <a:extLst>
+              <a:ext uri="{FF2B5EF4-FFF2-40B4-BE49-F238E27FC236}">
+                <a16:creationId xmlns:a16="http://schemas.microsoft.com/office/drawing/2014/main" id="{B3986487-D77E-5749-0CB6-B043103196A2}"/>
               </a:ext>
             </a:extLst>
           </p:cNvPr>
@@ -4737,54 +5076,9 @@
           <p:nvPr/>
         </p:nvCxnSpPr>
         <p:spPr>
-          <a:xfrm flipV="1">
-            <a:off x="8294697" y="3890665"/>
-            <a:ext cx="0" cy="778512"/>
-          </a:xfrm>
-          <a:prstGeom prst="straightConnector1">
-            <a:avLst/>
-          </a:prstGeom>
-          <a:ln w="57150" cap="flat" cmpd="sng" algn="ctr">
-            <a:solidFill>
-              <a:schemeClr val="accent1"/>
-            </a:solidFill>
-            <a:prstDash val="solid"/>
-            <a:round/>
-            <a:headEnd type="none" w="med" len="med"/>
-            <a:tailEnd type="arrow" w="med" len="med"/>
-          </a:ln>
-        </p:spPr>
-        <p:style>
-          <a:lnRef idx="0">
-            <a:scrgbClr r="0" g="0" b="0"/>
-          </a:lnRef>
-          <a:fillRef idx="0">
-            <a:scrgbClr r="0" g="0" b="0"/>
-          </a:fillRef>
-          <a:effectRef idx="0">
-            <a:scrgbClr r="0" g="0" b="0"/>
-          </a:effectRef>
-          <a:fontRef idx="minor">
-            <a:schemeClr val="tx1"/>
-          </a:fontRef>
-        </p:style>
-      </p:cxnSp>
-      <p:cxnSp>
-        <p:nvCxnSpPr>
-          <p:cNvPr id="42" name="Straight Connector 41">
-            <a:extLst>
-              <a:ext uri="{FF2B5EF4-FFF2-40B4-BE49-F238E27FC236}">
-                <a16:creationId xmlns:a16="http://schemas.microsoft.com/office/drawing/2014/main" id="{44E8210F-875A-0432-DEE9-4CDCC6665A7C}"/>
-              </a:ext>
-            </a:extLst>
-          </p:cNvPr>
-          <p:cNvCxnSpPr/>
-          <p:nvPr/>
-        </p:nvCxnSpPr>
-        <p:spPr>
           <a:xfrm flipH="1">
-            <a:off x="927166" y="4623457"/>
-            <a:ext cx="7358387" cy="0"/>
+            <a:off x="1737360" y="1363705"/>
+            <a:ext cx="7917861" cy="0"/>
           </a:xfrm>
           <a:prstGeom prst="line">
             <a:avLst/>
@@ -4808,10 +5102,10 @@
       </p:cxnSp>
       <p:cxnSp>
         <p:nvCxnSpPr>
-          <p:cNvPr id="43" name="Straight Connector 42">
-            <a:extLst>
-              <a:ext uri="{FF2B5EF4-FFF2-40B4-BE49-F238E27FC236}">
-                <a16:creationId xmlns:a16="http://schemas.microsoft.com/office/drawing/2014/main" id="{118D9707-863F-75C3-1084-7D2A88F8AFD4}"/>
+          <p:cNvPr id="61" name="Straight Connector 60">
+            <a:extLst>
+              <a:ext uri="{FF2B5EF4-FFF2-40B4-BE49-F238E27FC236}">
+                <a16:creationId xmlns:a16="http://schemas.microsoft.com/office/drawing/2014/main" id="{E018BF38-1A4F-AE25-C7C8-708DBC5D58F2}"/>
               </a:ext>
             </a:extLst>
           </p:cNvPr>
@@ -4822,8 +5116,8 @@
         </p:nvCxnSpPr>
         <p:spPr>
           <a:xfrm>
-            <a:off x="942406" y="4209288"/>
-            <a:ext cx="0" cy="414169"/>
+            <a:off x="1737360" y="1363705"/>
+            <a:ext cx="0" cy="1599775"/>
           </a:xfrm>
           <a:prstGeom prst="line">
             <a:avLst/>
@@ -4845,138 +5139,614 @@
           </a:fontRef>
         </p:style>
       </p:cxnSp>
-      <p:cxnSp>
-        <p:nvCxnSpPr>
-          <p:cNvPr id="46" name="Straight Arrow Connector 45">
-            <a:extLst>
-              <a:ext uri="{FF2B5EF4-FFF2-40B4-BE49-F238E27FC236}">
-                <a16:creationId xmlns:a16="http://schemas.microsoft.com/office/drawing/2014/main" id="{8BDFA182-522E-8CF6-A43D-57BB0041731C}"/>
-              </a:ext>
-            </a:extLst>
-          </p:cNvPr>
-          <p:cNvCxnSpPr>
-            <a:cxnSpLocks/>
-          </p:cNvCxnSpPr>
-          <p:nvPr/>
-        </p:nvCxnSpPr>
-        <p:spPr>
-          <a:xfrm>
-            <a:off x="9135052" y="3533388"/>
-            <a:ext cx="639884" cy="0"/>
-          </a:xfrm>
-          <a:prstGeom prst="straightConnector1">
-            <a:avLst/>
-          </a:prstGeom>
-          <a:ln w="57150" cap="flat" cmpd="sng" algn="ctr">
-            <a:solidFill>
-              <a:schemeClr val="accent1"/>
-            </a:solidFill>
-            <a:prstDash val="solid"/>
-            <a:round/>
-            <a:headEnd type="none" w="med" len="med"/>
-            <a:tailEnd type="arrow" w="med" len="med"/>
-          </a:ln>
-        </p:spPr>
-        <p:style>
-          <a:lnRef idx="0">
-            <a:scrgbClr r="0" g="0" b="0"/>
-          </a:lnRef>
-          <a:fillRef idx="0">
-            <a:scrgbClr r="0" g="0" b="0"/>
-          </a:fillRef>
-          <a:effectRef idx="0">
-            <a:scrgbClr r="0" g="0" b="0"/>
-          </a:effectRef>
-          <a:fontRef idx="minor">
-            <a:schemeClr val="tx1"/>
-          </a:fontRef>
-        </p:style>
-      </p:cxnSp>
-      <p:sp>
-        <p:nvSpPr>
-          <p:cNvPr id="48" name="AutoShape 2">
-            <a:extLst>
-              <a:ext uri="{FF2B5EF4-FFF2-40B4-BE49-F238E27FC236}">
-                <a16:creationId xmlns:a16="http://schemas.microsoft.com/office/drawing/2014/main" id="{F2B007B2-1D83-6F71-C166-6FFA99ED2C96}"/>
-              </a:ext>
-            </a:extLst>
-          </p:cNvPr>
-          <p:cNvSpPr>
-            <a:spLocks noChangeAspect="1" noChangeArrowheads="1"/>
-          </p:cNvSpPr>
-          <p:nvPr/>
-        </p:nvSpPr>
-        <p:spPr bwMode="auto">
-          <a:xfrm>
-            <a:off x="5943600" y="3276600"/>
-            <a:ext cx="304800" cy="304800"/>
-          </a:xfrm>
-          <a:prstGeom prst="rect">
-            <a:avLst/>
-          </a:prstGeom>
-          <a:noFill/>
-          <a:extLst>
-            <a:ext uri="{909E8E84-426E-40DD-AFC4-6F175D3DCCD1}">
-              <a14:hiddenFill xmlns:a14="http://schemas.microsoft.com/office/drawing/2010/main">
-                <a:solidFill>
-                  <a:srgbClr val="FFFFFF"/>
-                </a:solidFill>
-              </a14:hiddenFill>
-            </a:ext>
-          </a:extLst>
-        </p:spPr>
-        <p:txBody>
-          <a:bodyPr vert="horz" wrap="square" lIns="91440" tIns="45720" rIns="91440" bIns="45720" numCol="1" anchor="t" anchorCtr="0" compatLnSpc="1">
-            <a:prstTxWarp prst="textNoShape">
-              <a:avLst/>
-            </a:prstTxWarp>
-          </a:bodyPr>
-          <a:lstStyle/>
-          <a:p>
-            <a:endParaRPr lang="en-US"/>
-          </a:p>
-        </p:txBody>
-      </p:sp>
-      <p:pic>
-        <p:nvPicPr>
-          <p:cNvPr id="50" name="Picture 49">
-            <a:extLst>
-              <a:ext uri="{FF2B5EF4-FFF2-40B4-BE49-F238E27FC236}">
-                <a16:creationId xmlns:a16="http://schemas.microsoft.com/office/drawing/2014/main" id="{110065EC-3090-35B7-FDB9-C613E2DE7518}"/>
-              </a:ext>
-            </a:extLst>
-          </p:cNvPr>
-          <p:cNvPicPr>
-            <a:picLocks noChangeAspect="1"/>
-          </p:cNvPicPr>
-          <p:nvPr/>
-        </p:nvPicPr>
-        <p:blipFill>
-          <a:blip r:embed="rId6"/>
-          <a:stretch>
-            <a:fillRect/>
-          </a:stretch>
-        </p:blipFill>
-        <p:spPr>
-          <a:xfrm>
-            <a:off x="9941046" y="2437999"/>
-            <a:ext cx="1860249" cy="1452666"/>
-          </a:xfrm>
-          <a:prstGeom prst="rect">
-            <a:avLst/>
-          </a:prstGeom>
-        </p:spPr>
-      </p:pic>
     </p:spTree>
     <p:extLst>
       <p:ext uri="{BB962C8B-B14F-4D97-AF65-F5344CB8AC3E}">
-        <p14:creationId xmlns:p14="http://schemas.microsoft.com/office/powerpoint/2010/main" val="2621669581"/>
+        <p14:creationId xmlns:p14="http://schemas.microsoft.com/office/powerpoint/2010/main" val="2566389466"/>
       </p:ext>
     </p:extLst>
   </p:cSld>
   <p:clrMapOvr>
     <a:masterClrMapping/>
   </p:clrMapOvr>
+  <p:timing>
+    <p:tnLst>
+      <p:par>
+        <p:cTn id="1" dur="indefinite" restart="never" nodeType="tmRoot">
+          <p:childTnLst>
+            <p:seq concurrent="1" nextAc="seek">
+              <p:cTn id="2" dur="indefinite" nodeType="mainSeq">
+                <p:childTnLst>
+                  <p:par>
+                    <p:cTn id="3" fill="hold">
+                      <p:stCondLst>
+                        <p:cond delay="indefinite"/>
+                      </p:stCondLst>
+                      <p:childTnLst>
+                        <p:par>
+                          <p:cTn id="4" fill="hold">
+                            <p:stCondLst>
+                              <p:cond delay="0"/>
+                            </p:stCondLst>
+                            <p:childTnLst>
+                              <p:par>
+                                <p:cTn id="5" presetID="1" presetClass="entr" presetSubtype="0" fill="hold" grpId="0" nodeType="clickEffect">
+                                  <p:stCondLst>
+                                    <p:cond delay="0"/>
+                                  </p:stCondLst>
+                                  <p:childTnLst>
+                                    <p:set>
+                                      <p:cBhvr>
+                                        <p:cTn id="6" dur="1" fill="hold">
+                                          <p:stCondLst>
+                                            <p:cond delay="0"/>
+                                          </p:stCondLst>
+                                        </p:cTn>
+                                        <p:tgtEl>
+                                          <p:spTgt spid="17"/>
+                                        </p:tgtEl>
+                                        <p:attrNameLst>
+                                          <p:attrName>style.visibility</p:attrName>
+                                        </p:attrNameLst>
+                                      </p:cBhvr>
+                                      <p:to>
+                                        <p:strVal val="visible"/>
+                                      </p:to>
+                                    </p:set>
+                                  </p:childTnLst>
+                                </p:cTn>
+                              </p:par>
+                              <p:par>
+                                <p:cTn id="7" presetID="1" presetClass="entr" presetSubtype="0" fill="hold" nodeType="withEffect">
+                                  <p:stCondLst>
+                                    <p:cond delay="0"/>
+                                  </p:stCondLst>
+                                  <p:childTnLst>
+                                    <p:set>
+                                      <p:cBhvr>
+                                        <p:cTn id="8" dur="1" fill="hold">
+                                          <p:stCondLst>
+                                            <p:cond delay="0"/>
+                                          </p:stCondLst>
+                                        </p:cTn>
+                                        <p:tgtEl>
+                                          <p:spTgt spid="8"/>
+                                        </p:tgtEl>
+                                        <p:attrNameLst>
+                                          <p:attrName>style.visibility</p:attrName>
+                                        </p:attrNameLst>
+                                      </p:cBhvr>
+                                      <p:to>
+                                        <p:strVal val="visible"/>
+                                      </p:to>
+                                    </p:set>
+                                  </p:childTnLst>
+                                </p:cTn>
+                              </p:par>
+                              <p:par>
+                                <p:cTn id="9" presetID="1" presetClass="entr" presetSubtype="0" fill="hold" nodeType="withEffect">
+                                  <p:stCondLst>
+                                    <p:cond delay="0"/>
+                                  </p:stCondLst>
+                                  <p:childTnLst>
+                                    <p:set>
+                                      <p:cBhvr>
+                                        <p:cTn id="10" dur="1" fill="hold">
+                                          <p:stCondLst>
+                                            <p:cond delay="0"/>
+                                          </p:stCondLst>
+                                        </p:cTn>
+                                        <p:tgtEl>
+                                          <p:spTgt spid="21"/>
+                                        </p:tgtEl>
+                                        <p:attrNameLst>
+                                          <p:attrName>style.visibility</p:attrName>
+                                        </p:attrNameLst>
+                                      </p:cBhvr>
+                                      <p:to>
+                                        <p:strVal val="visible"/>
+                                      </p:to>
+                                    </p:set>
+                                  </p:childTnLst>
+                                </p:cTn>
+                              </p:par>
+                            </p:childTnLst>
+                          </p:cTn>
+                        </p:par>
+                      </p:childTnLst>
+                    </p:cTn>
+                  </p:par>
+                  <p:par>
+                    <p:cTn id="11" fill="hold">
+                      <p:stCondLst>
+                        <p:cond delay="indefinite"/>
+                      </p:stCondLst>
+                      <p:childTnLst>
+                        <p:par>
+                          <p:cTn id="12" fill="hold">
+                            <p:stCondLst>
+                              <p:cond delay="0"/>
+                            </p:stCondLst>
+                            <p:childTnLst>
+                              <p:par>
+                                <p:cTn id="13" presetID="1" presetClass="entr" presetSubtype="0" fill="hold" grpId="0" nodeType="clickEffect">
+                                  <p:stCondLst>
+                                    <p:cond delay="0"/>
+                                  </p:stCondLst>
+                                  <p:childTnLst>
+                                    <p:set>
+                                      <p:cBhvr>
+                                        <p:cTn id="14" dur="1" fill="hold">
+                                          <p:stCondLst>
+                                            <p:cond delay="0"/>
+                                          </p:stCondLst>
+                                        </p:cTn>
+                                        <p:tgtEl>
+                                          <p:spTgt spid="32"/>
+                                        </p:tgtEl>
+                                        <p:attrNameLst>
+                                          <p:attrName>style.visibility</p:attrName>
+                                        </p:attrNameLst>
+                                      </p:cBhvr>
+                                      <p:to>
+                                        <p:strVal val="visible"/>
+                                      </p:to>
+                                    </p:set>
+                                  </p:childTnLst>
+                                </p:cTn>
+                              </p:par>
+                              <p:par>
+                                <p:cTn id="15" presetID="1" presetClass="entr" presetSubtype="0" fill="hold" nodeType="withEffect">
+                                  <p:stCondLst>
+                                    <p:cond delay="0"/>
+                                  </p:stCondLst>
+                                  <p:childTnLst>
+                                    <p:set>
+                                      <p:cBhvr>
+                                        <p:cTn id="16" dur="1" fill="hold">
+                                          <p:stCondLst>
+                                            <p:cond delay="0"/>
+                                          </p:stCondLst>
+                                        </p:cTn>
+                                        <p:tgtEl>
+                                          <p:spTgt spid="26"/>
+                                        </p:tgtEl>
+                                        <p:attrNameLst>
+                                          <p:attrName>style.visibility</p:attrName>
+                                        </p:attrNameLst>
+                                      </p:cBhvr>
+                                      <p:to>
+                                        <p:strVal val="visible"/>
+                                      </p:to>
+                                    </p:set>
+                                  </p:childTnLst>
+                                </p:cTn>
+                              </p:par>
+                              <p:par>
+                                <p:cTn id="17" presetID="1" presetClass="entr" presetSubtype="0" fill="hold" grpId="0" nodeType="withEffect">
+                                  <p:stCondLst>
+                                    <p:cond delay="0"/>
+                                  </p:stCondLst>
+                                  <p:childTnLst>
+                                    <p:set>
+                                      <p:cBhvr>
+                                        <p:cTn id="18" dur="1" fill="hold">
+                                          <p:stCondLst>
+                                            <p:cond delay="0"/>
+                                          </p:stCondLst>
+                                        </p:cTn>
+                                        <p:tgtEl>
+                                          <p:spTgt spid="28"/>
+                                        </p:tgtEl>
+                                        <p:attrNameLst>
+                                          <p:attrName>style.visibility</p:attrName>
+                                        </p:attrNameLst>
+                                      </p:cBhvr>
+                                      <p:to>
+                                        <p:strVal val="visible"/>
+                                      </p:to>
+                                    </p:set>
+                                  </p:childTnLst>
+                                </p:cTn>
+                              </p:par>
+                              <p:par>
+                                <p:cTn id="19" presetID="1" presetClass="entr" presetSubtype="0" fill="hold" grpId="0" nodeType="withEffect">
+                                  <p:stCondLst>
+                                    <p:cond delay="0"/>
+                                  </p:stCondLst>
+                                  <p:childTnLst>
+                                    <p:set>
+                                      <p:cBhvr>
+                                        <p:cTn id="20" dur="1" fill="hold">
+                                          <p:stCondLst>
+                                            <p:cond delay="0"/>
+                                          </p:stCondLst>
+                                        </p:cTn>
+                                        <p:tgtEl>
+                                          <p:spTgt spid="22"/>
+                                        </p:tgtEl>
+                                        <p:attrNameLst>
+                                          <p:attrName>style.visibility</p:attrName>
+                                        </p:attrNameLst>
+                                      </p:cBhvr>
+                                      <p:to>
+                                        <p:strVal val="visible"/>
+                                      </p:to>
+                                    </p:set>
+                                  </p:childTnLst>
+                                </p:cTn>
+                              </p:par>
+                              <p:par>
+                                <p:cTn id="21" presetID="1" presetClass="entr" presetSubtype="0" fill="hold" nodeType="withEffect">
+                                  <p:stCondLst>
+                                    <p:cond delay="0"/>
+                                  </p:stCondLst>
+                                  <p:childTnLst>
+                                    <p:set>
+                                      <p:cBhvr>
+                                        <p:cTn id="22" dur="1" fill="hold">
+                                          <p:stCondLst>
+                                            <p:cond delay="0"/>
+                                          </p:stCondLst>
+                                        </p:cTn>
+                                        <p:tgtEl>
+                                          <p:spTgt spid="57"/>
+                                        </p:tgtEl>
+                                        <p:attrNameLst>
+                                          <p:attrName>style.visibility</p:attrName>
+                                        </p:attrNameLst>
+                                      </p:cBhvr>
+                                      <p:to>
+                                        <p:strVal val="visible"/>
+                                      </p:to>
+                                    </p:set>
+                                  </p:childTnLst>
+                                </p:cTn>
+                              </p:par>
+                              <p:par>
+                                <p:cTn id="23" presetID="1" presetClass="entr" presetSubtype="0" fill="hold" nodeType="withEffect">
+                                  <p:stCondLst>
+                                    <p:cond delay="0"/>
+                                  </p:stCondLst>
+                                  <p:childTnLst>
+                                    <p:set>
+                                      <p:cBhvr>
+                                        <p:cTn id="24" dur="1" fill="hold">
+                                          <p:stCondLst>
+                                            <p:cond delay="0"/>
+                                          </p:stCondLst>
+                                        </p:cTn>
+                                        <p:tgtEl>
+                                          <p:spTgt spid="59"/>
+                                        </p:tgtEl>
+                                        <p:attrNameLst>
+                                          <p:attrName>style.visibility</p:attrName>
+                                        </p:attrNameLst>
+                                      </p:cBhvr>
+                                      <p:to>
+                                        <p:strVal val="visible"/>
+                                      </p:to>
+                                    </p:set>
+                                  </p:childTnLst>
+                                </p:cTn>
+                              </p:par>
+                              <p:par>
+                                <p:cTn id="25" presetID="1" presetClass="entr" presetSubtype="0" fill="hold" nodeType="withEffect">
+                                  <p:stCondLst>
+                                    <p:cond delay="0"/>
+                                  </p:stCondLst>
+                                  <p:childTnLst>
+                                    <p:set>
+                                      <p:cBhvr>
+                                        <p:cTn id="26" dur="1" fill="hold">
+                                          <p:stCondLst>
+                                            <p:cond delay="0"/>
+                                          </p:stCondLst>
+                                        </p:cTn>
+                                        <p:tgtEl>
+                                          <p:spTgt spid="61"/>
+                                        </p:tgtEl>
+                                        <p:attrNameLst>
+                                          <p:attrName>style.visibility</p:attrName>
+                                        </p:attrNameLst>
+                                      </p:cBhvr>
+                                      <p:to>
+                                        <p:strVal val="visible"/>
+                                      </p:to>
+                                    </p:set>
+                                  </p:childTnLst>
+                                </p:cTn>
+                              </p:par>
+                            </p:childTnLst>
+                          </p:cTn>
+                        </p:par>
+                      </p:childTnLst>
+                    </p:cTn>
+                  </p:par>
+                  <p:par>
+                    <p:cTn id="27" fill="hold">
+                      <p:stCondLst>
+                        <p:cond delay="indefinite"/>
+                      </p:stCondLst>
+                      <p:childTnLst>
+                        <p:par>
+                          <p:cTn id="28" fill="hold">
+                            <p:stCondLst>
+                              <p:cond delay="0"/>
+                            </p:stCondLst>
+                            <p:childTnLst>
+                              <p:par>
+                                <p:cTn id="29" presetID="1" presetClass="entr" presetSubtype="0" fill="hold" grpId="0" nodeType="clickEffect">
+                                  <p:stCondLst>
+                                    <p:cond delay="0"/>
+                                  </p:stCondLst>
+                                  <p:childTnLst>
+                                    <p:set>
+                                      <p:cBhvr>
+                                        <p:cTn id="30" dur="1" fill="hold">
+                                          <p:stCondLst>
+                                            <p:cond delay="0"/>
+                                          </p:stCondLst>
+                                        </p:cTn>
+                                        <p:tgtEl>
+                                          <p:spTgt spid="37"/>
+                                        </p:tgtEl>
+                                        <p:attrNameLst>
+                                          <p:attrName>style.visibility</p:attrName>
+                                        </p:attrNameLst>
+                                      </p:cBhvr>
+                                      <p:to>
+                                        <p:strVal val="visible"/>
+                                      </p:to>
+                                    </p:set>
+                                  </p:childTnLst>
+                                </p:cTn>
+                              </p:par>
+                              <p:par>
+                                <p:cTn id="31" presetID="1" presetClass="entr" presetSubtype="0" fill="hold" grpId="0" nodeType="withEffect">
+                                  <p:stCondLst>
+                                    <p:cond delay="0"/>
+                                  </p:stCondLst>
+                                  <p:childTnLst>
+                                    <p:set>
+                                      <p:cBhvr>
+                                        <p:cTn id="32" dur="1" fill="hold">
+                                          <p:stCondLst>
+                                            <p:cond delay="0"/>
+                                          </p:stCondLst>
+                                        </p:cTn>
+                                        <p:tgtEl>
+                                          <p:spTgt spid="41"/>
+                                        </p:tgtEl>
+                                        <p:attrNameLst>
+                                          <p:attrName>style.visibility</p:attrName>
+                                        </p:attrNameLst>
+                                      </p:cBhvr>
+                                      <p:to>
+                                        <p:strVal val="visible"/>
+                                      </p:to>
+                                    </p:set>
+                                  </p:childTnLst>
+                                </p:cTn>
+                              </p:par>
+                              <p:par>
+                                <p:cTn id="33" presetID="1" presetClass="entr" presetSubtype="0" fill="hold" nodeType="withEffect">
+                                  <p:stCondLst>
+                                    <p:cond delay="0"/>
+                                  </p:stCondLst>
+                                  <p:childTnLst>
+                                    <p:set>
+                                      <p:cBhvr>
+                                        <p:cTn id="34" dur="1" fill="hold">
+                                          <p:stCondLst>
+                                            <p:cond delay="0"/>
+                                          </p:stCondLst>
+                                        </p:cTn>
+                                        <p:tgtEl>
+                                          <p:spTgt spid="40"/>
+                                        </p:tgtEl>
+                                        <p:attrNameLst>
+                                          <p:attrName>style.visibility</p:attrName>
+                                        </p:attrNameLst>
+                                      </p:cBhvr>
+                                      <p:to>
+                                        <p:strVal val="visible"/>
+                                      </p:to>
+                                    </p:set>
+                                  </p:childTnLst>
+                                </p:cTn>
+                              </p:par>
+                              <p:par>
+                                <p:cTn id="35" presetID="1" presetClass="entr" presetSubtype="0" fill="hold" nodeType="withEffect">
+                                  <p:stCondLst>
+                                    <p:cond delay="0"/>
+                                  </p:stCondLst>
+                                  <p:childTnLst>
+                                    <p:set>
+                                      <p:cBhvr>
+                                        <p:cTn id="36" dur="1" fill="hold">
+                                          <p:stCondLst>
+                                            <p:cond delay="0"/>
+                                          </p:stCondLst>
+                                        </p:cTn>
+                                        <p:tgtEl>
+                                          <p:spTgt spid="38"/>
+                                        </p:tgtEl>
+                                        <p:attrNameLst>
+                                          <p:attrName>style.visibility</p:attrName>
+                                        </p:attrNameLst>
+                                      </p:cBhvr>
+                                      <p:to>
+                                        <p:strVal val="visible"/>
+                                      </p:to>
+                                    </p:set>
+                                  </p:childTnLst>
+                                </p:cTn>
+                              </p:par>
+                              <p:par>
+                                <p:cTn id="37" presetID="1" presetClass="entr" presetSubtype="0" fill="hold" nodeType="withEffect">
+                                  <p:stCondLst>
+                                    <p:cond delay="0"/>
+                                  </p:stCondLst>
+                                  <p:childTnLst>
+                                    <p:set>
+                                      <p:cBhvr>
+                                        <p:cTn id="38" dur="1" fill="hold">
+                                          <p:stCondLst>
+                                            <p:cond delay="0"/>
+                                          </p:stCondLst>
+                                        </p:cTn>
+                                        <p:tgtEl>
+                                          <p:spTgt spid="45"/>
+                                        </p:tgtEl>
+                                        <p:attrNameLst>
+                                          <p:attrName>style.visibility</p:attrName>
+                                        </p:attrNameLst>
+                                      </p:cBhvr>
+                                      <p:to>
+                                        <p:strVal val="visible"/>
+                                      </p:to>
+                                    </p:set>
+                                  </p:childTnLst>
+                                </p:cTn>
+                              </p:par>
+                              <p:par>
+                                <p:cTn id="39" presetID="1" presetClass="entr" presetSubtype="0" fill="hold" grpId="0" nodeType="withEffect">
+                                  <p:stCondLst>
+                                    <p:cond delay="0"/>
+                                  </p:stCondLst>
+                                  <p:childTnLst>
+                                    <p:set>
+                                      <p:cBhvr>
+                                        <p:cTn id="40" dur="1" fill="hold">
+                                          <p:stCondLst>
+                                            <p:cond delay="0"/>
+                                          </p:stCondLst>
+                                        </p:cTn>
+                                        <p:tgtEl>
+                                          <p:spTgt spid="47"/>
+                                        </p:tgtEl>
+                                        <p:attrNameLst>
+                                          <p:attrName>style.visibility</p:attrName>
+                                        </p:attrNameLst>
+                                      </p:cBhvr>
+                                      <p:to>
+                                        <p:strVal val="visible"/>
+                                      </p:to>
+                                    </p:set>
+                                  </p:childTnLst>
+                                </p:cTn>
+                              </p:par>
+                            </p:childTnLst>
+                          </p:cTn>
+                        </p:par>
+                      </p:childTnLst>
+                    </p:cTn>
+                  </p:par>
+                  <p:par>
+                    <p:cTn id="41" fill="hold">
+                      <p:stCondLst>
+                        <p:cond delay="indefinite"/>
+                      </p:stCondLst>
+                      <p:childTnLst>
+                        <p:par>
+                          <p:cTn id="42" fill="hold">
+                            <p:stCondLst>
+                              <p:cond delay="0"/>
+                            </p:stCondLst>
+                            <p:childTnLst>
+                              <p:par>
+                                <p:cTn id="43" presetID="1" presetClass="entr" presetSubtype="0" fill="hold" nodeType="clickEffect">
+                                  <p:stCondLst>
+                                    <p:cond delay="0"/>
+                                  </p:stCondLst>
+                                  <p:childTnLst>
+                                    <p:set>
+                                      <p:cBhvr>
+                                        <p:cTn id="44" dur="1" fill="hold">
+                                          <p:stCondLst>
+                                            <p:cond delay="0"/>
+                                          </p:stCondLst>
+                                        </p:cTn>
+                                        <p:tgtEl>
+                                          <p:spTgt spid="34"/>
+                                        </p:tgtEl>
+                                        <p:attrNameLst>
+                                          <p:attrName>style.visibility</p:attrName>
+                                        </p:attrNameLst>
+                                      </p:cBhvr>
+                                      <p:to>
+                                        <p:strVal val="visible"/>
+                                      </p:to>
+                                    </p:set>
+                                  </p:childTnLst>
+                                </p:cTn>
+                              </p:par>
+                              <p:par>
+                                <p:cTn id="45" presetID="1" presetClass="entr" presetSubtype="0" fill="hold" grpId="0" nodeType="withEffect">
+                                  <p:stCondLst>
+                                    <p:cond delay="0"/>
+                                  </p:stCondLst>
+                                  <p:childTnLst>
+                                    <p:set>
+                                      <p:cBhvr>
+                                        <p:cTn id="46" dur="1" fill="hold">
+                                          <p:stCondLst>
+                                            <p:cond delay="0"/>
+                                          </p:stCondLst>
+                                        </p:cTn>
+                                        <p:tgtEl>
+                                          <p:spTgt spid="35"/>
+                                        </p:tgtEl>
+                                        <p:attrNameLst>
+                                          <p:attrName>style.visibility</p:attrName>
+                                        </p:attrNameLst>
+                                      </p:cBhvr>
+                                      <p:to>
+                                        <p:strVal val="visible"/>
+                                      </p:to>
+                                    </p:set>
+                                  </p:childTnLst>
+                                </p:cTn>
+                              </p:par>
+                            </p:childTnLst>
+                          </p:cTn>
+                        </p:par>
+                      </p:childTnLst>
+                    </p:cTn>
+                  </p:par>
+                </p:childTnLst>
+              </p:cTn>
+              <p:prevCondLst>
+                <p:cond evt="onPrev" delay="0">
+                  <p:tgtEl>
+                    <p:sldTgt/>
+                  </p:tgtEl>
+                </p:cond>
+              </p:prevCondLst>
+              <p:nextCondLst>
+                <p:cond evt="onNext" delay="0">
+                  <p:tgtEl>
+                    <p:sldTgt/>
+                  </p:tgtEl>
+                </p:cond>
+              </p:nextCondLst>
+            </p:seq>
+          </p:childTnLst>
+        </p:cTn>
+      </p:par>
+    </p:tnLst>
+    <p:bldLst>
+      <p:bldP spid="17" grpId="0" animBg="1"/>
+      <p:bldP spid="22" grpId="0" animBg="1"/>
+      <p:bldP spid="28" grpId="0"/>
+      <p:bldP spid="32" grpId="0" animBg="1"/>
+      <p:bldP spid="35" grpId="0"/>
+      <p:bldP spid="37" grpId="0" animBg="1"/>
+      <p:bldP spid="41" grpId="0" animBg="1"/>
+      <p:bldP spid="47" grpId="0"/>
+    </p:bldLst>
+  </p:timing>
 </p:sld>
 </file>
 

</xml_diff>